<commit_message>
feat(apdcat-migracio): stack options vertically and flag conditional start date
Co-Authored-By: Claude Opus 5.5 <noreply@anthropic.com>
</commit_message>
<xml_diff>
--- a/apdcat-migracio/apdcat-migracio.pptx
+++ b/apdcat-migracio/apdcat-migracio.pptx
@@ -7445,12 +7445,12 @@
         </p:nvSpPr>
         <p:spPr>
           <a:xfrm>
-            <a:off x="1397000" y="2064742"/>
-            <a:ext cx="6502400" cy="6005116"/>
+            <a:off x="1397000" y="2025253"/>
+            <a:ext cx="13462000" cy="2679700"/>
           </a:xfrm>
           <a:prstGeom prst="roundRect">
             <a:avLst>
-              <a:gd name="adj" fmla="val 2960"/>
+              <a:gd name="adj" fmla="val 6635"/>
             </a:avLst>
           </a:prstGeom>
           <a:solidFill>
@@ -7496,12 +7496,12 @@
         </p:nvSpPr>
         <p:spPr>
           <a:xfrm>
-            <a:off x="1397000" y="2115542"/>
-            <a:ext cx="6502400" cy="5954316"/>
+            <a:off x="1397000" y="2076053"/>
+            <a:ext cx="13462000" cy="2628900"/>
           </a:xfrm>
           <a:prstGeom prst="roundRect">
             <a:avLst>
-              <a:gd name="adj" fmla="val 2986"/>
+              <a:gd name="adj" fmla="val 6763"/>
             </a:avLst>
           </a:prstGeom>
           <a:solidFill>
@@ -7540,8 +7540,8 @@
         </p:nvSpPr>
         <p:spPr>
           <a:xfrm>
-            <a:off x="1905000" y="2623542"/>
-            <a:ext cx="5562600" cy="355600"/>
+            <a:off x="1905000" y="2603103"/>
+            <a:ext cx="3576836" cy="355600"/>
           </a:xfrm>
           <a:prstGeom prst="rect">
             <a:avLst/>
@@ -7577,8 +7577,8 @@
         </p:nvSpPr>
         <p:spPr>
           <a:xfrm>
-            <a:off x="1905000" y="3106142"/>
-            <a:ext cx="5511800" cy="828675"/>
+            <a:off x="1905000" y="3085703"/>
+            <a:ext cx="3526036" cy="1143000"/>
           </a:xfrm>
           <a:prstGeom prst="rect">
             <a:avLst/>
@@ -7614,8 +7614,8 @@
         </p:nvSpPr>
         <p:spPr>
           <a:xfrm>
-            <a:off x="1905000" y="4239617"/>
-            <a:ext cx="5562600" cy="731441"/>
+            <a:off x="6015236" y="2872383"/>
+            <a:ext cx="3251200" cy="731441"/>
           </a:xfrm>
           <a:prstGeom prst="rect">
             <a:avLst/>
@@ -7651,8 +7651,8 @@
         </p:nvSpPr>
         <p:spPr>
           <a:xfrm>
-            <a:off x="1905000" y="5047258"/>
-            <a:ext cx="5562600" cy="228600"/>
+            <a:off x="6015236" y="3680023"/>
+            <a:ext cx="3251200" cy="228600"/>
           </a:xfrm>
           <a:prstGeom prst="rect">
             <a:avLst/>
@@ -7675,102 +7675,20 @@
                 </a:solidFill>
                 <a:latin typeface="Roboto"/>
               </a:rPr>
-              <a:t>Arrencada · 28 de febrer de 2027</a:t>
-            </a:r>
-          </a:p>
-        </p:txBody>
-      </p:sp>
-      <p:sp>
-        <p:nvSpPr>
-          <p:cNvPr id="13" name="Rectangle 12"/>
-          <p:cNvSpPr/>
-          <p:nvPr/>
-        </p:nvSpPr>
-        <p:spPr>
-          <a:xfrm>
-            <a:off x="1905000" y="5631458"/>
-            <a:ext cx="5486400" cy="495300"/>
-          </a:xfrm>
-          <a:prstGeom prst="rect">
-            <a:avLst/>
-          </a:prstGeom>
-          <a:noFill/>
-          <a:effectLst/>
-          <a:ln>
-            <a:noFill/>
-          </a:ln>
-        </p:spPr>
-        <p:style>
-          <a:lnRef idx="1">
-            <a:schemeClr val="accent1"/>
-          </a:lnRef>
-          <a:fillRef idx="3">
-            <a:schemeClr val="accent1"/>
-          </a:fillRef>
-          <a:effectRef idx="2">
-            <a:schemeClr val="accent1"/>
-          </a:effectRef>
-          <a:fontRef idx="minor">
-            <a:schemeClr val="lt1"/>
-          </a:fontRef>
-        </p:style>
-        <p:txBody>
-          <a:bodyPr rtlCol="0" anchor="ctr"/>
-          <a:lstStyle/>
-          <a:p/>
-        </p:txBody>
-      </p:sp>
-      <p:sp>
-        <p:nvSpPr>
-          <p:cNvPr id="14" name="Rectangle 13"/>
-          <p:cNvSpPr/>
-          <p:nvPr/>
-        </p:nvSpPr>
-        <p:spPr>
-          <a:xfrm>
-            <a:off x="1905000" y="5631458"/>
-            <a:ext cx="5486400" cy="12700"/>
-          </a:xfrm>
-          <a:prstGeom prst="rect">
-            <a:avLst/>
-          </a:prstGeom>
-          <a:solidFill>
-            <a:srgbClr val="D4DEE3"/>
-          </a:solidFill>
-          <a:effectLst/>
-          <a:ln>
-            <a:noFill/>
-          </a:ln>
-        </p:spPr>
-        <p:style>
-          <a:lnRef idx="1">
-            <a:schemeClr val="accent1"/>
-          </a:lnRef>
-          <a:fillRef idx="3">
-            <a:schemeClr val="accent1"/>
-          </a:fillRef>
-          <a:effectRef idx="2">
-            <a:schemeClr val="accent1"/>
-          </a:effectRef>
-          <a:fontRef idx="minor">
-            <a:schemeClr val="lt1"/>
-          </a:fontRef>
-        </p:style>
-        <p:txBody>
-          <a:bodyPr rtlCol="0" anchor="ctr"/>
-          <a:lstStyle/>
-          <a:p/>
-        </p:txBody>
-      </p:sp>
-      <p:sp>
-        <p:nvSpPr>
-          <p:cNvPr id="15" name="TextBox 14"/>
+              <a:t>Arrencada · 28 de febrer de 2027*</a:t>
+            </a:r>
+          </a:p>
+        </p:txBody>
+      </p:sp>
+      <p:sp>
+        <p:nvSpPr>
+          <p:cNvPr id="13" name="TextBox 12"/>
           <p:cNvSpPr txBox="1"/>
           <p:nvPr/>
         </p:nvSpPr>
         <p:spPr>
           <a:xfrm>
-            <a:off x="1905000" y="5771158"/>
+            <a:off x="9799836" y="2533253"/>
             <a:ext cx="1437084" cy="228600"/>
           </a:xfrm>
           <a:prstGeom prst="rect">
@@ -7801,13 +7719,13 @@
       </p:sp>
       <p:sp>
         <p:nvSpPr>
-          <p:cNvPr id="16" name="TextBox 15"/>
+          <p:cNvPr id="14" name="TextBox 13"/>
           <p:cNvSpPr txBox="1"/>
           <p:nvPr/>
         </p:nvSpPr>
         <p:spPr>
           <a:xfrm>
-            <a:off x="5982097" y="5771158"/>
+            <a:off x="12941697" y="2533253"/>
             <a:ext cx="1409303" cy="228600"/>
           </a:xfrm>
           <a:prstGeom prst="rect">
@@ -7838,14 +7756,14 @@
       </p:sp>
       <p:sp>
         <p:nvSpPr>
-          <p:cNvPr id="17" name="Rectangle 16"/>
-          <p:cNvSpPr/>
-          <p:nvPr/>
-        </p:nvSpPr>
-        <p:spPr>
-          <a:xfrm>
-            <a:off x="1905000" y="6126758"/>
-            <a:ext cx="5486400" cy="495300"/>
+          <p:cNvPr id="15" name="Rectangle 14"/>
+          <p:cNvSpPr/>
+          <p:nvPr/>
+        </p:nvSpPr>
+        <p:spPr>
+          <a:xfrm>
+            <a:off x="9799836" y="2888853"/>
+            <a:ext cx="4551164" cy="495300"/>
           </a:xfrm>
           <a:prstGeom prst="rect">
             <a:avLst/>
@@ -7878,14 +7796,14 @@
       </p:sp>
       <p:sp>
         <p:nvSpPr>
-          <p:cNvPr id="18" name="Rectangle 17"/>
-          <p:cNvSpPr/>
-          <p:nvPr/>
-        </p:nvSpPr>
-        <p:spPr>
-          <a:xfrm>
-            <a:off x="1905000" y="6126758"/>
-            <a:ext cx="5486400" cy="12700"/>
+          <p:cNvPr id="16" name="Rectangle 15"/>
+          <p:cNvSpPr/>
+          <p:nvPr/>
+        </p:nvSpPr>
+        <p:spPr>
+          <a:xfrm>
+            <a:off x="9799836" y="2888853"/>
+            <a:ext cx="4551164" cy="12700"/>
           </a:xfrm>
           <a:prstGeom prst="rect">
             <a:avLst/>
@@ -7920,13 +7838,13 @@
       </p:sp>
       <p:sp>
         <p:nvSpPr>
-          <p:cNvPr id="19" name="TextBox 18"/>
+          <p:cNvPr id="17" name="TextBox 16"/>
           <p:cNvSpPr txBox="1"/>
           <p:nvPr/>
         </p:nvSpPr>
         <p:spPr>
           <a:xfrm>
-            <a:off x="1905000" y="6266458"/>
+            <a:off x="9799836" y="3028553"/>
             <a:ext cx="2654895" cy="228600"/>
           </a:xfrm>
           <a:prstGeom prst="rect">
@@ -7957,13 +7875,13 @@
       </p:sp>
       <p:sp>
         <p:nvSpPr>
-          <p:cNvPr id="20" name="TextBox 19"/>
+          <p:cNvPr id="18" name="TextBox 17"/>
           <p:cNvSpPr txBox="1"/>
           <p:nvPr/>
         </p:nvSpPr>
         <p:spPr>
           <a:xfrm>
-            <a:off x="5581055" y="6266458"/>
+            <a:off x="12540655" y="3028553"/>
             <a:ext cx="1810345" cy="228600"/>
           </a:xfrm>
           <a:prstGeom prst="rect">
@@ -7994,14 +7912,14 @@
       </p:sp>
       <p:sp>
         <p:nvSpPr>
-          <p:cNvPr id="21" name="Rectangle 20"/>
-          <p:cNvSpPr/>
-          <p:nvPr/>
-        </p:nvSpPr>
-        <p:spPr>
-          <a:xfrm>
-            <a:off x="1905000" y="6622058"/>
-            <a:ext cx="5486400" cy="495300"/>
+          <p:cNvPr id="19" name="Rectangle 18"/>
+          <p:cNvSpPr/>
+          <p:nvPr/>
+        </p:nvSpPr>
+        <p:spPr>
+          <a:xfrm>
+            <a:off x="9799836" y="3384153"/>
+            <a:ext cx="4551164" cy="495300"/>
           </a:xfrm>
           <a:prstGeom prst="rect">
             <a:avLst/>
@@ -8034,14 +7952,14 @@
       </p:sp>
       <p:sp>
         <p:nvSpPr>
-          <p:cNvPr id="22" name="Rectangle 21"/>
-          <p:cNvSpPr/>
-          <p:nvPr/>
-        </p:nvSpPr>
-        <p:spPr>
-          <a:xfrm>
-            <a:off x="1905000" y="6622058"/>
-            <a:ext cx="5486400" cy="12700"/>
+          <p:cNvPr id="20" name="Rectangle 19"/>
+          <p:cNvSpPr/>
+          <p:nvPr/>
+        </p:nvSpPr>
+        <p:spPr>
+          <a:xfrm>
+            <a:off x="9799836" y="3384153"/>
+            <a:ext cx="4551164" cy="12700"/>
           </a:xfrm>
           <a:prstGeom prst="rect">
             <a:avLst/>
@@ -8076,13 +7994,13 @@
       </p:sp>
       <p:sp>
         <p:nvSpPr>
-          <p:cNvPr id="23" name="TextBox 22"/>
+          <p:cNvPr id="21" name="TextBox 20"/>
           <p:cNvSpPr txBox="1"/>
           <p:nvPr/>
         </p:nvSpPr>
         <p:spPr>
           <a:xfrm>
-            <a:off x="1905000" y="6761758"/>
+            <a:off x="9799836" y="3523853"/>
             <a:ext cx="1867694" cy="228600"/>
           </a:xfrm>
           <a:prstGeom prst="rect">
@@ -8113,13 +8031,13 @@
       </p:sp>
       <p:sp>
         <p:nvSpPr>
-          <p:cNvPr id="24" name="TextBox 23"/>
+          <p:cNvPr id="22" name="TextBox 21"/>
           <p:cNvSpPr txBox="1"/>
           <p:nvPr/>
         </p:nvSpPr>
         <p:spPr>
           <a:xfrm>
-            <a:off x="5581055" y="6761758"/>
+            <a:off x="12540655" y="3523853"/>
             <a:ext cx="1810345" cy="228600"/>
           </a:xfrm>
           <a:prstGeom prst="rect">
@@ -8150,14 +8068,14 @@
       </p:sp>
       <p:sp>
         <p:nvSpPr>
-          <p:cNvPr id="25" name="Rectangle 24"/>
-          <p:cNvSpPr/>
-          <p:nvPr/>
-        </p:nvSpPr>
-        <p:spPr>
-          <a:xfrm>
-            <a:off x="1905000" y="7117358"/>
-            <a:ext cx="5486400" cy="495300"/>
+          <p:cNvPr id="23" name="Rectangle 22"/>
+          <p:cNvSpPr/>
+          <p:nvPr/>
+        </p:nvSpPr>
+        <p:spPr>
+          <a:xfrm>
+            <a:off x="9799836" y="3879453"/>
+            <a:ext cx="4551164" cy="495300"/>
           </a:xfrm>
           <a:prstGeom prst="rect">
             <a:avLst/>
@@ -8190,14 +8108,14 @@
       </p:sp>
       <p:sp>
         <p:nvSpPr>
-          <p:cNvPr id="26" name="Rectangle 25"/>
-          <p:cNvSpPr/>
-          <p:nvPr/>
-        </p:nvSpPr>
-        <p:spPr>
-          <a:xfrm>
-            <a:off x="1905000" y="7117358"/>
-            <a:ext cx="5486400" cy="12700"/>
+          <p:cNvPr id="24" name="Rectangle 23"/>
+          <p:cNvSpPr/>
+          <p:nvPr/>
+        </p:nvSpPr>
+        <p:spPr>
+          <a:xfrm>
+            <a:off x="9799836" y="3879453"/>
+            <a:ext cx="4551164" cy="12700"/>
           </a:xfrm>
           <a:prstGeom prst="rect">
             <a:avLst/>
@@ -8232,13 +8150,13 @@
       </p:sp>
       <p:sp>
         <p:nvSpPr>
-          <p:cNvPr id="27" name="TextBox 26"/>
+          <p:cNvPr id="25" name="TextBox 24"/>
           <p:cNvSpPr txBox="1"/>
           <p:nvPr/>
         </p:nvSpPr>
         <p:spPr>
           <a:xfrm>
-            <a:off x="1905000" y="7257058"/>
+            <a:off x="9799836" y="4019153"/>
             <a:ext cx="2217341" cy="228600"/>
           </a:xfrm>
           <a:prstGeom prst="rect">
@@ -8269,13 +8187,13 @@
       </p:sp>
       <p:sp>
         <p:nvSpPr>
-          <p:cNvPr id="28" name="TextBox 27"/>
+          <p:cNvPr id="26" name="TextBox 25"/>
           <p:cNvSpPr txBox="1"/>
           <p:nvPr/>
         </p:nvSpPr>
         <p:spPr>
           <a:xfrm>
-            <a:off x="5341541" y="7257058"/>
+            <a:off x="12301141" y="4019153"/>
             <a:ext cx="2049859" cy="228600"/>
           </a:xfrm>
           <a:prstGeom prst="rect">
@@ -8306,18 +8224,18 @@
       </p:sp>
       <p:sp>
         <p:nvSpPr>
-          <p:cNvPr id="29" name="Rounded Rectangle 28"/>
-          <p:cNvSpPr/>
-          <p:nvPr/>
-        </p:nvSpPr>
-        <p:spPr>
-          <a:xfrm>
-            <a:off x="8356600" y="2064742"/>
-            <a:ext cx="6502400" cy="6005116"/>
+          <p:cNvPr id="27" name="Rounded Rectangle 26"/>
+          <p:cNvSpPr/>
+          <p:nvPr/>
+        </p:nvSpPr>
+        <p:spPr>
+          <a:xfrm>
+            <a:off x="1397000" y="4958953"/>
+            <a:ext cx="13462000" cy="2679700"/>
           </a:xfrm>
           <a:prstGeom prst="roundRect">
             <a:avLst>
-              <a:gd name="adj" fmla="val 2960"/>
+              <a:gd name="adj" fmla="val 6635"/>
             </a:avLst>
           </a:prstGeom>
           <a:solidFill>
@@ -8357,18 +8275,18 @@
       </p:sp>
       <p:sp>
         <p:nvSpPr>
-          <p:cNvPr id="30" name="Rounded Rectangle 29"/>
-          <p:cNvSpPr/>
-          <p:nvPr/>
-        </p:nvSpPr>
-        <p:spPr>
-          <a:xfrm>
-            <a:off x="8356600" y="2115542"/>
-            <a:ext cx="6502400" cy="5954316"/>
+          <p:cNvPr id="28" name="Rounded Rectangle 27"/>
+          <p:cNvSpPr/>
+          <p:nvPr/>
+        </p:nvSpPr>
+        <p:spPr>
+          <a:xfrm>
+            <a:off x="1397000" y="5009753"/>
+            <a:ext cx="13462000" cy="2628900"/>
           </a:xfrm>
           <a:prstGeom prst="roundRect">
             <a:avLst>
-              <a:gd name="adj" fmla="val 2986"/>
+              <a:gd name="adj" fmla="val 6763"/>
             </a:avLst>
           </a:prstGeom>
           <a:solidFill>
@@ -8401,14 +8319,14 @@
       </p:sp>
       <p:sp>
         <p:nvSpPr>
-          <p:cNvPr id="31" name="TextBox 30"/>
+          <p:cNvPr id="29" name="TextBox 28"/>
           <p:cNvSpPr txBox="1"/>
           <p:nvPr/>
         </p:nvSpPr>
         <p:spPr>
           <a:xfrm>
-            <a:off x="8864600" y="2623542"/>
-            <a:ext cx="5562600" cy="355600"/>
+            <a:off x="1905000" y="5679678"/>
+            <a:ext cx="3576836" cy="355600"/>
           </a:xfrm>
           <a:prstGeom prst="rect">
             <a:avLst/>
@@ -8438,14 +8356,14 @@
       </p:sp>
       <p:sp>
         <p:nvSpPr>
-          <p:cNvPr id="32" name="TextBox 31"/>
+          <p:cNvPr id="30" name="TextBox 29"/>
           <p:cNvSpPr txBox="1"/>
           <p:nvPr/>
         </p:nvSpPr>
         <p:spPr>
           <a:xfrm>
-            <a:off x="8864600" y="3106142"/>
-            <a:ext cx="5511800" cy="828675"/>
+            <a:off x="1905000" y="6162278"/>
+            <a:ext cx="3526036" cy="857250"/>
           </a:xfrm>
           <a:prstGeom prst="rect">
             <a:avLst/>
@@ -8475,14 +8393,14 @@
       </p:sp>
       <p:sp>
         <p:nvSpPr>
-          <p:cNvPr id="33" name="TextBox 32"/>
+          <p:cNvPr id="31" name="TextBox 30"/>
           <p:cNvSpPr txBox="1"/>
           <p:nvPr/>
         </p:nvSpPr>
         <p:spPr>
           <a:xfrm>
-            <a:off x="8864600" y="4239617"/>
-            <a:ext cx="5562600" cy="731441"/>
+            <a:off x="6015236" y="5806083"/>
+            <a:ext cx="3251200" cy="731441"/>
           </a:xfrm>
           <a:prstGeom prst="rect">
             <a:avLst/>
@@ -8512,14 +8430,14 @@
       </p:sp>
       <p:sp>
         <p:nvSpPr>
-          <p:cNvPr id="34" name="TextBox 33"/>
+          <p:cNvPr id="32" name="TextBox 31"/>
           <p:cNvSpPr txBox="1"/>
           <p:nvPr/>
         </p:nvSpPr>
         <p:spPr>
           <a:xfrm>
-            <a:off x="8864600" y="5047258"/>
-            <a:ext cx="5562600" cy="228600"/>
+            <a:off x="6015236" y="6613723"/>
+            <a:ext cx="3251200" cy="228600"/>
           </a:xfrm>
           <a:prstGeom prst="rect">
             <a:avLst/>
@@ -8549,95 +8467,13 @@
       </p:sp>
       <p:sp>
         <p:nvSpPr>
-          <p:cNvPr id="35" name="Rectangle 34"/>
-          <p:cNvSpPr/>
-          <p:nvPr/>
-        </p:nvSpPr>
-        <p:spPr>
-          <a:xfrm>
-            <a:off x="8864600" y="5631458"/>
-            <a:ext cx="5486400" cy="495300"/>
-          </a:xfrm>
-          <a:prstGeom prst="rect">
-            <a:avLst/>
-          </a:prstGeom>
-          <a:noFill/>
-          <a:effectLst/>
-          <a:ln>
-            <a:noFill/>
-          </a:ln>
-        </p:spPr>
-        <p:style>
-          <a:lnRef idx="1">
-            <a:schemeClr val="accent1"/>
-          </a:lnRef>
-          <a:fillRef idx="3">
-            <a:schemeClr val="accent1"/>
-          </a:fillRef>
-          <a:effectRef idx="2">
-            <a:schemeClr val="accent1"/>
-          </a:effectRef>
-          <a:fontRef idx="minor">
-            <a:schemeClr val="lt1"/>
-          </a:fontRef>
-        </p:style>
-        <p:txBody>
-          <a:bodyPr rtlCol="0" anchor="ctr"/>
-          <a:lstStyle/>
-          <a:p/>
-        </p:txBody>
-      </p:sp>
-      <p:sp>
-        <p:nvSpPr>
-          <p:cNvPr id="36" name="Rectangle 35"/>
-          <p:cNvSpPr/>
-          <p:nvPr/>
-        </p:nvSpPr>
-        <p:spPr>
-          <a:xfrm>
-            <a:off x="8864600" y="5631458"/>
-            <a:ext cx="5486400" cy="12700"/>
-          </a:xfrm>
-          <a:prstGeom prst="rect">
-            <a:avLst/>
-          </a:prstGeom>
-          <a:solidFill>
-            <a:srgbClr val="D4DEE3"/>
-          </a:solidFill>
-          <a:effectLst/>
-          <a:ln>
-            <a:noFill/>
-          </a:ln>
-        </p:spPr>
-        <p:style>
-          <a:lnRef idx="1">
-            <a:schemeClr val="accent1"/>
-          </a:lnRef>
-          <a:fillRef idx="3">
-            <a:schemeClr val="accent1"/>
-          </a:fillRef>
-          <a:effectRef idx="2">
-            <a:schemeClr val="accent1"/>
-          </a:effectRef>
-          <a:fontRef idx="minor">
-            <a:schemeClr val="lt1"/>
-          </a:fontRef>
-        </p:style>
-        <p:txBody>
-          <a:bodyPr rtlCol="0" anchor="ctr"/>
-          <a:lstStyle/>
-          <a:p/>
-        </p:txBody>
-      </p:sp>
-      <p:sp>
-        <p:nvSpPr>
-          <p:cNvPr id="37" name="TextBox 36"/>
+          <p:cNvPr id="33" name="TextBox 32"/>
           <p:cNvSpPr txBox="1"/>
           <p:nvPr/>
         </p:nvSpPr>
         <p:spPr>
           <a:xfrm>
-            <a:off x="8864600" y="5771158"/>
+            <a:off x="9799836" y="5466953"/>
             <a:ext cx="1437084" cy="228600"/>
           </a:xfrm>
           <a:prstGeom prst="rect">
@@ -8668,13 +8504,13 @@
       </p:sp>
       <p:sp>
         <p:nvSpPr>
-          <p:cNvPr id="38" name="TextBox 37"/>
+          <p:cNvPr id="34" name="TextBox 33"/>
           <p:cNvSpPr txBox="1"/>
           <p:nvPr/>
         </p:nvSpPr>
         <p:spPr>
           <a:xfrm>
-            <a:off x="13305433" y="5771158"/>
+            <a:off x="13305433" y="5466953"/>
             <a:ext cx="1045567" cy="228600"/>
           </a:xfrm>
           <a:prstGeom prst="rect">
@@ -8705,14 +8541,14 @@
       </p:sp>
       <p:sp>
         <p:nvSpPr>
-          <p:cNvPr id="39" name="Rectangle 38"/>
-          <p:cNvSpPr/>
-          <p:nvPr/>
-        </p:nvSpPr>
-        <p:spPr>
-          <a:xfrm>
-            <a:off x="8864600" y="6126758"/>
-            <a:ext cx="5486400" cy="495300"/>
+          <p:cNvPr id="35" name="Rectangle 34"/>
+          <p:cNvSpPr/>
+          <p:nvPr/>
+        </p:nvSpPr>
+        <p:spPr>
+          <a:xfrm>
+            <a:off x="9799836" y="5822553"/>
+            <a:ext cx="4551164" cy="495300"/>
           </a:xfrm>
           <a:prstGeom prst="rect">
             <a:avLst/>
@@ -8745,14 +8581,14 @@
       </p:sp>
       <p:sp>
         <p:nvSpPr>
-          <p:cNvPr id="40" name="Rectangle 39"/>
-          <p:cNvSpPr/>
-          <p:nvPr/>
-        </p:nvSpPr>
-        <p:spPr>
-          <a:xfrm>
-            <a:off x="8864600" y="6126758"/>
-            <a:ext cx="5486400" cy="12700"/>
+          <p:cNvPr id="36" name="Rectangle 35"/>
+          <p:cNvSpPr/>
+          <p:nvPr/>
+        </p:nvSpPr>
+        <p:spPr>
+          <a:xfrm>
+            <a:off x="9799836" y="5822553"/>
+            <a:ext cx="4551164" cy="12700"/>
           </a:xfrm>
           <a:prstGeom prst="rect">
             <a:avLst/>
@@ -8787,13 +8623,13 @@
       </p:sp>
       <p:sp>
         <p:nvSpPr>
-          <p:cNvPr id="41" name="TextBox 40"/>
+          <p:cNvPr id="37" name="TextBox 36"/>
           <p:cNvSpPr txBox="1"/>
           <p:nvPr/>
         </p:nvSpPr>
         <p:spPr>
           <a:xfrm>
-            <a:off x="8864600" y="6266458"/>
+            <a:off x="9799836" y="5962253"/>
             <a:ext cx="1887141" cy="228600"/>
           </a:xfrm>
           <a:prstGeom prst="rect">
@@ -8824,13 +8660,13 @@
       </p:sp>
       <p:sp>
         <p:nvSpPr>
-          <p:cNvPr id="42" name="TextBox 41"/>
+          <p:cNvPr id="38" name="TextBox 37"/>
           <p:cNvSpPr txBox="1"/>
           <p:nvPr/>
         </p:nvSpPr>
         <p:spPr>
           <a:xfrm>
-            <a:off x="12249150" y="6266458"/>
+            <a:off x="12249150" y="5962253"/>
             <a:ext cx="2101850" cy="228600"/>
           </a:xfrm>
           <a:prstGeom prst="rect">
@@ -8861,14 +8697,14 @@
       </p:sp>
       <p:sp>
         <p:nvSpPr>
-          <p:cNvPr id="43" name="Rectangle 42"/>
-          <p:cNvSpPr/>
-          <p:nvPr/>
-        </p:nvSpPr>
-        <p:spPr>
-          <a:xfrm>
-            <a:off x="8864600" y="6622058"/>
-            <a:ext cx="5486400" cy="495300"/>
+          <p:cNvPr id="39" name="Rectangle 38"/>
+          <p:cNvSpPr/>
+          <p:nvPr/>
+        </p:nvSpPr>
+        <p:spPr>
+          <a:xfrm>
+            <a:off x="9799836" y="6317853"/>
+            <a:ext cx="4551164" cy="495300"/>
           </a:xfrm>
           <a:prstGeom prst="rect">
             <a:avLst/>
@@ -8901,14 +8737,14 @@
       </p:sp>
       <p:sp>
         <p:nvSpPr>
-          <p:cNvPr id="44" name="Rectangle 43"/>
-          <p:cNvSpPr/>
-          <p:nvPr/>
-        </p:nvSpPr>
-        <p:spPr>
-          <a:xfrm>
-            <a:off x="8864600" y="6622058"/>
-            <a:ext cx="5486400" cy="12700"/>
+          <p:cNvPr id="40" name="Rectangle 39"/>
+          <p:cNvSpPr/>
+          <p:nvPr/>
+        </p:nvSpPr>
+        <p:spPr>
+          <a:xfrm>
+            <a:off x="9799836" y="6317853"/>
+            <a:ext cx="4551164" cy="12700"/>
           </a:xfrm>
           <a:prstGeom prst="rect">
             <a:avLst/>
@@ -8943,13 +8779,13 @@
       </p:sp>
       <p:sp>
         <p:nvSpPr>
-          <p:cNvPr id="45" name="TextBox 44"/>
+          <p:cNvPr id="41" name="TextBox 40"/>
           <p:cNvSpPr txBox="1"/>
           <p:nvPr/>
         </p:nvSpPr>
         <p:spPr>
           <a:xfrm>
-            <a:off x="8864600" y="6761758"/>
+            <a:off x="9799836" y="6457553"/>
             <a:ext cx="1867694" cy="228600"/>
           </a:xfrm>
           <a:prstGeom prst="rect">
@@ -8980,13 +8816,13 @@
       </p:sp>
       <p:sp>
         <p:nvSpPr>
-          <p:cNvPr id="46" name="TextBox 45"/>
+          <p:cNvPr id="42" name="TextBox 41"/>
           <p:cNvSpPr txBox="1"/>
           <p:nvPr/>
         </p:nvSpPr>
         <p:spPr>
           <a:xfrm>
-            <a:off x="12249150" y="6761758"/>
+            <a:off x="12249150" y="6457553"/>
             <a:ext cx="2101850" cy="228600"/>
           </a:xfrm>
           <a:prstGeom prst="rect">
@@ -9017,14 +8853,14 @@
       </p:sp>
       <p:sp>
         <p:nvSpPr>
-          <p:cNvPr id="47" name="Rectangle 46"/>
-          <p:cNvSpPr/>
-          <p:nvPr/>
-        </p:nvSpPr>
-        <p:spPr>
-          <a:xfrm>
-            <a:off x="8864600" y="7117358"/>
-            <a:ext cx="5486400" cy="495300"/>
+          <p:cNvPr id="43" name="Rectangle 42"/>
+          <p:cNvSpPr/>
+          <p:nvPr/>
+        </p:nvSpPr>
+        <p:spPr>
+          <a:xfrm>
+            <a:off x="9799836" y="6813153"/>
+            <a:ext cx="4551164" cy="495300"/>
           </a:xfrm>
           <a:prstGeom prst="rect">
             <a:avLst/>
@@ -9057,14 +8893,14 @@
       </p:sp>
       <p:sp>
         <p:nvSpPr>
-          <p:cNvPr id="48" name="Rectangle 47"/>
-          <p:cNvSpPr/>
-          <p:nvPr/>
-        </p:nvSpPr>
-        <p:spPr>
-          <a:xfrm>
-            <a:off x="8864600" y="7117358"/>
-            <a:ext cx="5486400" cy="12700"/>
+          <p:cNvPr id="44" name="Rectangle 43"/>
+          <p:cNvSpPr/>
+          <p:nvPr/>
+        </p:nvSpPr>
+        <p:spPr>
+          <a:xfrm>
+            <a:off x="9799836" y="6813153"/>
+            <a:ext cx="4551164" cy="12700"/>
           </a:xfrm>
           <a:prstGeom prst="rect">
             <a:avLst/>
@@ -9099,13 +8935,13 @@
       </p:sp>
       <p:sp>
         <p:nvSpPr>
-          <p:cNvPr id="49" name="TextBox 48"/>
+          <p:cNvPr id="45" name="TextBox 44"/>
           <p:cNvSpPr txBox="1"/>
           <p:nvPr/>
         </p:nvSpPr>
         <p:spPr>
           <a:xfrm>
-            <a:off x="8864600" y="7257058"/>
+            <a:off x="9799836" y="6952853"/>
             <a:ext cx="2217341" cy="228600"/>
           </a:xfrm>
           <a:prstGeom prst="rect">
@@ -9136,13 +8972,13 @@
       </p:sp>
       <p:sp>
         <p:nvSpPr>
-          <p:cNvPr id="50" name="TextBox 49"/>
+          <p:cNvPr id="46" name="TextBox 45"/>
           <p:cNvSpPr txBox="1"/>
           <p:nvPr/>
         </p:nvSpPr>
         <p:spPr>
           <a:xfrm>
-            <a:off x="12301141" y="7257058"/>
+            <a:off x="12301141" y="6952853"/>
             <a:ext cx="2049859" cy="228600"/>
           </a:xfrm>
           <a:prstGeom prst="rect">
@@ -9173,7 +9009,44 @@
       </p:sp>
       <p:sp>
         <p:nvSpPr>
-          <p:cNvPr id="51" name="TextBox 50"/>
+          <p:cNvPr id="47" name="TextBox 46"/>
+          <p:cNvSpPr txBox="1"/>
+          <p:nvPr/>
+        </p:nvSpPr>
+        <p:spPr>
+          <a:xfrm>
+            <a:off x="1397000" y="7841853"/>
+            <a:ext cx="13538200" cy="267494"/>
+          </a:xfrm>
+          <a:prstGeom prst="rect">
+            <a:avLst/>
+          </a:prstGeom>
+          <a:noFill/>
+        </p:spPr>
+        <p:txBody>
+          <a:bodyPr wrap="none" lIns="0" rIns="0" tIns="0" bIns="0" anchor="t"/>
+          <a:lstStyle/>
+          <a:p>
+            <a:pPr algn="l">
+              <a:lnSpc>
+                <a:spcPct val="154999"/>
+              </a:lnSpc>
+            </a:pPr>
+            <a:r>
+              <a:rPr sz="1360" b="0" i="0">
+                <a:solidFill>
+                  <a:srgbClr val="3D5C66"/>
+                </a:solidFill>
+                <a:latin typeface="Roboto"/>
+              </a:rPr>
+              <a:t>* Data condicionada al desplegament dels evolutius de producte.</a:t>
+            </a:r>
+          </a:p>
+        </p:txBody>
+      </p:sp>
+      <p:sp>
+        <p:nvSpPr>
+          <p:cNvPr id="48" name="TextBox 47"/>
           <p:cNvSpPr txBox="1"/>
           <p:nvPr/>
         </p:nvSpPr>

</xml_diff>

<commit_message>
feat(apdcat-migracio): restore side-by-side options with phased reveal
Co-Authored-By: Claude Opus 5.5 <noreply@anthropic.com>
</commit_message>
<xml_diff>
--- a/apdcat-migracio/apdcat-migracio.pptx
+++ b/apdcat-migracio/apdcat-migracio.pptx
@@ -7437,1616 +7437,1825 @@
           </a:p>
         </p:txBody>
       </p:sp>
-      <p:sp>
-        <p:nvSpPr>
-          <p:cNvPr id="7" name="Rounded Rectangle 6"/>
-          <p:cNvSpPr/>
-          <p:nvPr/>
-        </p:nvSpPr>
-        <p:spPr>
-          <a:xfrm>
-            <a:off x="1397000" y="2025253"/>
-            <a:ext cx="13462000" cy="2679700"/>
-          </a:xfrm>
-          <a:prstGeom prst="roundRect">
-            <a:avLst>
-              <a:gd name="adj" fmla="val 6635"/>
-            </a:avLst>
-          </a:prstGeom>
-          <a:solidFill>
-            <a:srgbClr val="7FB927"/>
-          </a:solidFill>
-          <a:effectLst/>
-          <a:ln>
-            <a:noFill/>
-          </a:ln>
-          <a:effectLst>
-            <a:outerShdw blurRad="203200" dist="25400" dir="5400000" algn="ctr" rotWithShape="0">
-              <a:srgbClr val="003040">
-                <a:alpha val="6000"/>
-              </a:srgbClr>
-            </a:outerShdw>
-          </a:effectLst>
-        </p:spPr>
-        <p:style>
-          <a:lnRef idx="1">
-            <a:schemeClr val="accent1"/>
-          </a:lnRef>
-          <a:fillRef idx="3">
-            <a:schemeClr val="accent1"/>
-          </a:fillRef>
-          <a:effectRef idx="2">
-            <a:schemeClr val="accent1"/>
-          </a:effectRef>
-          <a:fontRef idx="minor">
-            <a:schemeClr val="lt1"/>
-          </a:fontRef>
-        </p:style>
-        <p:txBody>
-          <a:bodyPr rtlCol="0" anchor="ctr"/>
-          <a:lstStyle/>
-          <a:p/>
-        </p:txBody>
-      </p:sp>
-      <p:sp>
-        <p:nvSpPr>
-          <p:cNvPr id="8" name="Rounded Rectangle 7"/>
-          <p:cNvSpPr/>
-          <p:nvPr/>
-        </p:nvSpPr>
-        <p:spPr>
-          <a:xfrm>
-            <a:off x="1397000" y="2076053"/>
-            <a:ext cx="13462000" cy="2628900"/>
-          </a:xfrm>
-          <a:prstGeom prst="roundRect">
-            <a:avLst>
-              <a:gd name="adj" fmla="val 6763"/>
-            </a:avLst>
-          </a:prstGeom>
-          <a:solidFill>
-            <a:srgbClr val="ECF0F3"/>
-          </a:solidFill>
-          <a:effectLst/>
-          <a:ln>
-            <a:noFill/>
-          </a:ln>
-        </p:spPr>
-        <p:style>
-          <a:lnRef idx="1">
-            <a:schemeClr val="accent1"/>
-          </a:lnRef>
-          <a:fillRef idx="3">
-            <a:schemeClr val="accent1"/>
-          </a:fillRef>
-          <a:effectRef idx="2">
-            <a:schemeClr val="accent1"/>
-          </a:effectRef>
-          <a:fontRef idx="minor">
-            <a:schemeClr val="lt1"/>
-          </a:fontRef>
-        </p:style>
-        <p:txBody>
-          <a:bodyPr rtlCol="0" anchor="ctr"/>
-          <a:lstStyle/>
-          <a:p/>
-        </p:txBody>
-      </p:sp>
-      <p:sp>
-        <p:nvSpPr>
-          <p:cNvPr id="9" name="TextBox 8"/>
-          <p:cNvSpPr txBox="1"/>
-          <p:nvPr/>
-        </p:nvSpPr>
-        <p:spPr>
-          <a:xfrm>
-            <a:off x="1905000" y="2603103"/>
-            <a:ext cx="3576836" cy="355600"/>
-          </a:xfrm>
-          <a:prstGeom prst="rect">
-            <a:avLst/>
-          </a:prstGeom>
-          <a:noFill/>
-        </p:spPr>
-        <p:txBody>
-          <a:bodyPr wrap="none" lIns="0" rIns="0" tIns="0" bIns="0" anchor="t"/>
-          <a:lstStyle/>
-          <a:p>
-            <a:pPr algn="l">
-              <a:lnSpc>
-                <a:spcPct val="120000"/>
-              </a:lnSpc>
-            </a:pPr>
-            <a:r>
-              <a:rPr sz="2400" b="1" i="0">
-                <a:solidFill>
-                  <a:srgbClr val="003040"/>
-                </a:solidFill>
-                <a:latin typeface="Roboto"/>
-              </a:rPr>
-              <a:t>Gestiona + Anexa</a:t>
-            </a:r>
-          </a:p>
-        </p:txBody>
-      </p:sp>
-      <p:sp>
-        <p:nvSpPr>
-          <p:cNvPr id="10" name="TextBox 9"/>
-          <p:cNvSpPr txBox="1"/>
-          <p:nvPr/>
-        </p:nvSpPr>
-        <p:spPr>
-          <a:xfrm>
-            <a:off x="1905000" y="3085703"/>
-            <a:ext cx="3526036" cy="1143000"/>
-          </a:xfrm>
-          <a:prstGeom prst="rect">
-            <a:avLst/>
-          </a:prstGeom>
-          <a:noFill/>
-        </p:spPr>
-        <p:txBody>
-          <a:bodyPr wrap="square" lIns="0" rIns="0" tIns="0" bIns="0" anchor="t"/>
-          <a:lstStyle/>
-          <a:p>
-            <a:pPr algn="l">
-              <a:lnSpc>
-                <a:spcPct val="150000"/>
-              </a:lnSpc>
-            </a:pPr>
-            <a:r>
-              <a:rPr sz="1500" b="0" i="0">
-                <a:solidFill>
-                  <a:srgbClr val="3D5C66"/>
-                </a:solidFill>
-                <a:latin typeface="Roboto"/>
-              </a:rPr>
-              <a:t>Traslladem la tramitació administrativa a Gestiona i mantenim algunes funcionalitats del projecte Factory a Anexa.</a:t>
-            </a:r>
-          </a:p>
-        </p:txBody>
-      </p:sp>
-      <p:sp>
-        <p:nvSpPr>
-          <p:cNvPr id="11" name="TextBox 10"/>
-          <p:cNvSpPr txBox="1"/>
-          <p:nvPr/>
-        </p:nvSpPr>
-        <p:spPr>
-          <a:xfrm>
-            <a:off x="6015236" y="2872383"/>
-            <a:ext cx="3251200" cy="731441"/>
-          </a:xfrm>
-          <a:prstGeom prst="rect">
-            <a:avLst/>
-          </a:prstGeom>
-          <a:noFill/>
-        </p:spPr>
-        <p:txBody>
-          <a:bodyPr wrap="none" lIns="0" rIns="0" tIns="0" bIns="0" anchor="t"/>
-          <a:lstStyle/>
-          <a:p>
-            <a:pPr algn="l">
-              <a:lnSpc>
-                <a:spcPct val="100000"/>
-              </a:lnSpc>
-            </a:pPr>
-            <a:r>
-              <a:rPr sz="5760" b="1" i="0">
-                <a:solidFill>
-                  <a:srgbClr val="7FB927"/>
-                </a:solidFill>
-                <a:latin typeface="Roboto"/>
-              </a:rPr>
-              <a:t>1T 2027</a:t>
-            </a:r>
-          </a:p>
-        </p:txBody>
-      </p:sp>
-      <p:sp>
-        <p:nvSpPr>
-          <p:cNvPr id="12" name="TextBox 11"/>
-          <p:cNvSpPr txBox="1"/>
-          <p:nvPr/>
-        </p:nvSpPr>
-        <p:spPr>
-          <a:xfrm>
-            <a:off x="6015236" y="3680023"/>
-            <a:ext cx="3251200" cy="228600"/>
-          </a:xfrm>
-          <a:prstGeom prst="rect">
-            <a:avLst/>
-          </a:prstGeom>
-          <a:noFill/>
-        </p:spPr>
-        <p:txBody>
-          <a:bodyPr wrap="none" lIns="0" rIns="0" tIns="0" bIns="0" anchor="t"/>
-          <a:lstStyle/>
-          <a:p>
-            <a:pPr algn="l">
-              <a:lnSpc>
-                <a:spcPct val="120000"/>
-              </a:lnSpc>
-            </a:pPr>
-            <a:r>
-              <a:rPr sz="1520" b="0" i="0">
-                <a:solidFill>
-                  <a:srgbClr val="3D5C66"/>
-                </a:solidFill>
-                <a:latin typeface="Roboto"/>
-              </a:rPr>
-              <a:t>Arrencada · 28 de febrer de 2027*</a:t>
-            </a:r>
-          </a:p>
-        </p:txBody>
-      </p:sp>
-      <p:sp>
-        <p:nvSpPr>
-          <p:cNvPr id="13" name="TextBox 12"/>
-          <p:cNvSpPr txBox="1"/>
-          <p:nvPr/>
-        </p:nvSpPr>
-        <p:spPr>
-          <a:xfrm>
-            <a:off x="9799836" y="2533253"/>
-            <a:ext cx="1437084" cy="228600"/>
-          </a:xfrm>
-          <a:prstGeom prst="rect">
-            <a:avLst/>
-          </a:prstGeom>
-          <a:noFill/>
-        </p:spPr>
-        <p:txBody>
-          <a:bodyPr wrap="none" lIns="0" rIns="0" tIns="0" bIns="0" anchor="t"/>
-          <a:lstStyle/>
-          <a:p>
-            <a:pPr algn="l">
-              <a:lnSpc>
-                <a:spcPct val="120000"/>
-              </a:lnSpc>
-            </a:pPr>
-            <a:r>
-              <a:rPr sz="1472" b="0" i="0">
-                <a:solidFill>
-                  <a:srgbClr val="3D5C66"/>
-                </a:solidFill>
-                <a:latin typeface="Roboto"/>
-              </a:rPr>
-              <a:t>Inici del projecte</a:t>
-            </a:r>
-          </a:p>
-        </p:txBody>
-      </p:sp>
-      <p:sp>
-        <p:nvSpPr>
-          <p:cNvPr id="14" name="TextBox 13"/>
-          <p:cNvSpPr txBox="1"/>
-          <p:nvPr/>
-        </p:nvSpPr>
-        <p:spPr>
-          <a:xfrm>
-            <a:off x="12941697" y="2533253"/>
-            <a:ext cx="1409303" cy="228600"/>
-          </a:xfrm>
-          <a:prstGeom prst="rect">
-            <a:avLst/>
-          </a:prstGeom>
-          <a:noFill/>
-        </p:spPr>
-        <p:txBody>
-          <a:bodyPr wrap="none" lIns="0" rIns="0" tIns="0" bIns="0" anchor="t"/>
-          <a:lstStyle/>
-          <a:p>
-            <a:pPr algn="r">
-              <a:lnSpc>
-                <a:spcPct val="120000"/>
-              </a:lnSpc>
-            </a:pPr>
-            <a:r>
-              <a:rPr sz="1472" b="0" i="0">
-                <a:solidFill>
-                  <a:srgbClr val="003040"/>
-                </a:solidFill>
-                <a:latin typeface="Roboto"/>
-              </a:rPr>
-              <a:t>Novembre 2026</a:t>
-            </a:r>
-          </a:p>
-        </p:txBody>
-      </p:sp>
-      <p:sp>
-        <p:nvSpPr>
-          <p:cNvPr id="15" name="Rectangle 14"/>
-          <p:cNvSpPr/>
-          <p:nvPr/>
-        </p:nvSpPr>
-        <p:spPr>
-          <a:xfrm>
-            <a:off x="9799836" y="2888853"/>
-            <a:ext cx="4551164" cy="495300"/>
-          </a:xfrm>
-          <a:prstGeom prst="rect">
-            <a:avLst/>
-          </a:prstGeom>
-          <a:noFill/>
-          <a:effectLst/>
-          <a:ln>
-            <a:noFill/>
-          </a:ln>
-        </p:spPr>
-        <p:style>
-          <a:lnRef idx="1">
-            <a:schemeClr val="accent1"/>
-          </a:lnRef>
-          <a:fillRef idx="3">
-            <a:schemeClr val="accent1"/>
-          </a:fillRef>
-          <a:effectRef idx="2">
-            <a:schemeClr val="accent1"/>
-          </a:effectRef>
-          <a:fontRef idx="minor">
-            <a:schemeClr val="lt1"/>
-          </a:fontRef>
-        </p:style>
-        <p:txBody>
-          <a:bodyPr rtlCol="0" anchor="ctr"/>
-          <a:lstStyle/>
-          <a:p/>
-        </p:txBody>
-      </p:sp>
-      <p:sp>
-        <p:nvSpPr>
-          <p:cNvPr id="16" name="Rectangle 15"/>
-          <p:cNvSpPr/>
-          <p:nvPr/>
-        </p:nvSpPr>
-        <p:spPr>
-          <a:xfrm>
-            <a:off x="9799836" y="2888853"/>
-            <a:ext cx="4551164" cy="12700"/>
-          </a:xfrm>
-          <a:prstGeom prst="rect">
-            <a:avLst/>
-          </a:prstGeom>
-          <a:solidFill>
-            <a:srgbClr val="D4DEE3"/>
-          </a:solidFill>
-          <a:effectLst/>
-          <a:ln>
-            <a:noFill/>
-          </a:ln>
-        </p:spPr>
-        <p:style>
-          <a:lnRef idx="1">
-            <a:schemeClr val="accent1"/>
-          </a:lnRef>
-          <a:fillRef idx="3">
-            <a:schemeClr val="accent1"/>
-          </a:fillRef>
-          <a:effectRef idx="2">
-            <a:schemeClr val="accent1"/>
-          </a:effectRef>
-          <a:fontRef idx="minor">
-            <a:schemeClr val="lt1"/>
-          </a:fontRef>
-        </p:style>
-        <p:txBody>
-          <a:bodyPr rtlCol="0" anchor="ctr"/>
-          <a:lstStyle/>
-          <a:p/>
-        </p:txBody>
-      </p:sp>
-      <p:sp>
-        <p:nvSpPr>
-          <p:cNvPr id="17" name="TextBox 16"/>
-          <p:cNvSpPr txBox="1"/>
-          <p:nvPr/>
-        </p:nvSpPr>
-        <p:spPr>
-          <a:xfrm>
-            <a:off x="9799836" y="3028553"/>
-            <a:ext cx="2654895" cy="228600"/>
-          </a:xfrm>
-          <a:prstGeom prst="rect">
-            <a:avLst/>
-          </a:prstGeom>
-          <a:noFill/>
-        </p:spPr>
-        <p:txBody>
-          <a:bodyPr wrap="none" lIns="0" rIns="0" tIns="0" bIns="0" anchor="t"/>
-          <a:lstStyle/>
-          <a:p>
-            <a:pPr algn="l">
-              <a:lnSpc>
-                <a:spcPct val="120000"/>
-              </a:lnSpc>
-            </a:pPr>
-            <a:r>
-              <a:rPr sz="1472" b="0" i="0">
-                <a:solidFill>
-                  <a:srgbClr val="3D5C66"/>
-                </a:solidFill>
-                <a:latin typeface="Roboto"/>
-              </a:rPr>
-              <a:t>Migració d'expedients i registre</a:t>
-            </a:r>
-          </a:p>
-        </p:txBody>
-      </p:sp>
-      <p:sp>
-        <p:nvSpPr>
-          <p:cNvPr id="18" name="TextBox 17"/>
-          <p:cNvSpPr txBox="1"/>
-          <p:nvPr/>
-        </p:nvSpPr>
-        <p:spPr>
-          <a:xfrm>
-            <a:off x="12540655" y="3028553"/>
-            <a:ext cx="1810345" cy="228600"/>
-          </a:xfrm>
-          <a:prstGeom prst="rect">
-            <a:avLst/>
-          </a:prstGeom>
-          <a:noFill/>
-        </p:spPr>
-        <p:txBody>
-          <a:bodyPr wrap="none" lIns="0" rIns="0" tIns="0" bIns="0" anchor="t"/>
-          <a:lstStyle/>
-          <a:p>
-            <a:pPr algn="r">
-              <a:lnSpc>
-                <a:spcPct val="120000"/>
-              </a:lnSpc>
-            </a:pPr>
-            <a:r>
-              <a:rPr sz="1472" b="0" i="0">
-                <a:solidFill>
-                  <a:srgbClr val="003040"/>
-                </a:solidFill>
-                <a:latin typeface="Roboto"/>
-              </a:rPr>
-              <a:t>28 de febrer de 2027</a:t>
-            </a:r>
-          </a:p>
-        </p:txBody>
-      </p:sp>
-      <p:sp>
-        <p:nvSpPr>
-          <p:cNvPr id="19" name="Rectangle 18"/>
-          <p:cNvSpPr/>
-          <p:nvPr/>
-        </p:nvSpPr>
-        <p:spPr>
-          <a:xfrm>
-            <a:off x="9799836" y="3384153"/>
-            <a:ext cx="4551164" cy="495300"/>
-          </a:xfrm>
-          <a:prstGeom prst="rect">
-            <a:avLst/>
-          </a:prstGeom>
-          <a:noFill/>
-          <a:effectLst/>
-          <a:ln>
-            <a:noFill/>
-          </a:ln>
-        </p:spPr>
-        <p:style>
-          <a:lnRef idx="1">
-            <a:schemeClr val="accent1"/>
-          </a:lnRef>
-          <a:fillRef idx="3">
-            <a:schemeClr val="accent1"/>
-          </a:fillRef>
-          <a:effectRef idx="2">
-            <a:schemeClr val="accent1"/>
-          </a:effectRef>
-          <a:fontRef idx="minor">
-            <a:schemeClr val="lt1"/>
-          </a:fontRef>
-        </p:style>
-        <p:txBody>
-          <a:bodyPr rtlCol="0" anchor="ctr"/>
-          <a:lstStyle/>
-          <a:p/>
-        </p:txBody>
-      </p:sp>
-      <p:sp>
-        <p:nvSpPr>
-          <p:cNvPr id="20" name="Rectangle 19"/>
-          <p:cNvSpPr/>
-          <p:nvPr/>
-        </p:nvSpPr>
-        <p:spPr>
-          <a:xfrm>
-            <a:off x="9799836" y="3384153"/>
-            <a:ext cx="4551164" cy="12700"/>
-          </a:xfrm>
-          <a:prstGeom prst="rect">
-            <a:avLst/>
-          </a:prstGeom>
-          <a:solidFill>
-            <a:srgbClr val="D4DEE3"/>
-          </a:solidFill>
-          <a:effectLst/>
-          <a:ln>
-            <a:noFill/>
-          </a:ln>
-        </p:spPr>
-        <p:style>
-          <a:lnRef idx="1">
-            <a:schemeClr val="accent1"/>
-          </a:lnRef>
-          <a:fillRef idx="3">
-            <a:schemeClr val="accent1"/>
-          </a:fillRef>
-          <a:effectRef idx="2">
-            <a:schemeClr val="accent1"/>
-          </a:effectRef>
-          <a:fontRef idx="minor">
-            <a:schemeClr val="lt1"/>
-          </a:fontRef>
-        </p:style>
-        <p:txBody>
-          <a:bodyPr rtlCol="0" anchor="ctr"/>
-          <a:lstStyle/>
-          <a:p/>
-        </p:txBody>
-      </p:sp>
-      <p:sp>
-        <p:nvSpPr>
-          <p:cNvPr id="21" name="TextBox 20"/>
-          <p:cNvSpPr txBox="1"/>
-          <p:nvPr/>
-        </p:nvSpPr>
-        <p:spPr>
-          <a:xfrm>
-            <a:off x="9799836" y="3523853"/>
-            <a:ext cx="1867694" cy="228600"/>
-          </a:xfrm>
-          <a:prstGeom prst="rect">
-            <a:avLst/>
-          </a:prstGeom>
-          <a:noFill/>
-        </p:spPr>
-        <p:txBody>
-          <a:bodyPr wrap="none" lIns="0" rIns="0" tIns="0" bIns="0" anchor="t"/>
-          <a:lstStyle/>
-          <a:p>
-            <a:pPr algn="l">
-              <a:lnSpc>
-                <a:spcPct val="120000"/>
-              </a:lnSpc>
-            </a:pPr>
-            <a:r>
-              <a:rPr sz="1472" b="0" i="0">
-                <a:solidFill>
-                  <a:srgbClr val="3D5C66"/>
-                </a:solidFill>
-                <a:latin typeface="Roboto"/>
-              </a:rPr>
-              <a:t>Evolutius de producte</a:t>
-            </a:r>
-          </a:p>
-        </p:txBody>
-      </p:sp>
-      <p:sp>
-        <p:nvSpPr>
-          <p:cNvPr id="22" name="TextBox 21"/>
-          <p:cNvSpPr txBox="1"/>
-          <p:nvPr/>
-        </p:nvSpPr>
-        <p:spPr>
-          <a:xfrm>
-            <a:off x="12540655" y="3523853"/>
-            <a:ext cx="1810345" cy="228600"/>
-          </a:xfrm>
-          <a:prstGeom prst="rect">
-            <a:avLst/>
-          </a:prstGeom>
-          <a:noFill/>
-        </p:spPr>
-        <p:txBody>
-          <a:bodyPr wrap="none" lIns="0" rIns="0" tIns="0" bIns="0" anchor="t"/>
-          <a:lstStyle/>
-          <a:p>
-            <a:pPr algn="r">
-              <a:lnSpc>
-                <a:spcPct val="120000"/>
-              </a:lnSpc>
-            </a:pPr>
-            <a:r>
-              <a:rPr sz="1472" b="0" i="0">
-                <a:solidFill>
-                  <a:srgbClr val="003040"/>
-                </a:solidFill>
-                <a:latin typeface="Roboto"/>
-              </a:rPr>
-              <a:t>28 de febrer de 2027</a:t>
-            </a:r>
-          </a:p>
-        </p:txBody>
-      </p:sp>
-      <p:sp>
-        <p:nvSpPr>
-          <p:cNvPr id="23" name="Rectangle 22"/>
-          <p:cNvSpPr/>
-          <p:nvPr/>
-        </p:nvSpPr>
-        <p:spPr>
-          <a:xfrm>
-            <a:off x="9799836" y="3879453"/>
-            <a:ext cx="4551164" cy="495300"/>
-          </a:xfrm>
-          <a:prstGeom prst="rect">
-            <a:avLst/>
-          </a:prstGeom>
-          <a:noFill/>
-          <a:effectLst/>
-          <a:ln>
-            <a:noFill/>
-          </a:ln>
-        </p:spPr>
-        <p:style>
-          <a:lnRef idx="1">
-            <a:schemeClr val="accent1"/>
-          </a:lnRef>
-          <a:fillRef idx="3">
-            <a:schemeClr val="accent1"/>
-          </a:fillRef>
-          <a:effectRef idx="2">
-            <a:schemeClr val="accent1"/>
-          </a:effectRef>
-          <a:fontRef idx="minor">
-            <a:schemeClr val="lt1"/>
-          </a:fontRef>
-        </p:style>
-        <p:txBody>
-          <a:bodyPr rtlCol="0" anchor="ctr"/>
-          <a:lstStyle/>
-          <a:p/>
-        </p:txBody>
-      </p:sp>
-      <p:sp>
-        <p:nvSpPr>
-          <p:cNvPr id="24" name="Rectangle 23"/>
-          <p:cNvSpPr/>
-          <p:nvPr/>
-        </p:nvSpPr>
-        <p:spPr>
-          <a:xfrm>
-            <a:off x="9799836" y="3879453"/>
-            <a:ext cx="4551164" cy="12700"/>
-          </a:xfrm>
-          <a:prstGeom prst="rect">
-            <a:avLst/>
-          </a:prstGeom>
-          <a:solidFill>
-            <a:srgbClr val="D4DEE3"/>
-          </a:solidFill>
-          <a:effectLst/>
-          <a:ln>
-            <a:noFill/>
-          </a:ln>
-        </p:spPr>
-        <p:style>
-          <a:lnRef idx="1">
-            <a:schemeClr val="accent1"/>
-          </a:lnRef>
-          <a:fillRef idx="3">
-            <a:schemeClr val="accent1"/>
-          </a:fillRef>
-          <a:effectRef idx="2">
-            <a:schemeClr val="accent1"/>
-          </a:effectRef>
-          <a:fontRef idx="minor">
-            <a:schemeClr val="lt1"/>
-          </a:fontRef>
-        </p:style>
-        <p:txBody>
-          <a:bodyPr rtlCol="0" anchor="ctr"/>
-          <a:lstStyle/>
-          <a:p/>
-        </p:txBody>
-      </p:sp>
-      <p:sp>
-        <p:nvSpPr>
-          <p:cNvPr id="25" name="TextBox 24"/>
-          <p:cNvSpPr txBox="1"/>
-          <p:nvPr/>
-        </p:nvSpPr>
-        <p:spPr>
-          <a:xfrm>
-            <a:off x="9799836" y="4019153"/>
-            <a:ext cx="2217341" cy="228600"/>
-          </a:xfrm>
-          <a:prstGeom prst="rect">
-            <a:avLst/>
-          </a:prstGeom>
-          <a:noFill/>
-        </p:spPr>
-        <p:txBody>
-          <a:bodyPr wrap="none" lIns="0" rIns="0" tIns="0" bIns="0" anchor="t"/>
-          <a:lstStyle/>
-          <a:p>
-            <a:pPr algn="l">
-              <a:lnSpc>
-                <a:spcPct val="120000"/>
-              </a:lnSpc>
-            </a:pPr>
-            <a:r>
-              <a:rPr sz="1472" b="0" i="0">
-                <a:solidFill>
-                  <a:srgbClr val="3D5C66"/>
-                </a:solidFill>
-                <a:latin typeface="Roboto"/>
-              </a:rPr>
-              <a:t>Projecte Gestiona Factory</a:t>
-            </a:r>
-          </a:p>
-        </p:txBody>
-      </p:sp>
-      <p:sp>
-        <p:nvSpPr>
-          <p:cNvPr id="26" name="TextBox 25"/>
-          <p:cNvSpPr txBox="1"/>
-          <p:nvPr/>
-        </p:nvSpPr>
-        <p:spPr>
-          <a:xfrm>
-            <a:off x="12301141" y="4019153"/>
-            <a:ext cx="2049859" cy="228600"/>
-          </a:xfrm>
-          <a:prstGeom prst="rect">
-            <a:avLst/>
-          </a:prstGeom>
-          <a:noFill/>
-        </p:spPr>
-        <p:txBody>
-          <a:bodyPr wrap="none" lIns="0" rIns="0" tIns="0" bIns="0" anchor="t"/>
-          <a:lstStyle/>
-          <a:p>
-            <a:pPr algn="r">
-              <a:lnSpc>
-                <a:spcPct val="120000"/>
-              </a:lnSpc>
-            </a:pPr>
-            <a:r>
-              <a:rPr sz="1472" b="0" i="0">
-                <a:solidFill>
-                  <a:srgbClr val="003040"/>
-                </a:solidFill>
-                <a:latin typeface="Roboto"/>
-              </a:rPr>
-              <a:t>Gener – setembre 2027</a:t>
-            </a:r>
-          </a:p>
-        </p:txBody>
-      </p:sp>
-      <p:sp>
-        <p:nvSpPr>
-          <p:cNvPr id="27" name="Rounded Rectangle 26"/>
-          <p:cNvSpPr/>
-          <p:nvPr/>
-        </p:nvSpPr>
-        <p:spPr>
-          <a:xfrm>
-            <a:off x="1397000" y="4958953"/>
-            <a:ext cx="13462000" cy="2679700"/>
-          </a:xfrm>
-          <a:prstGeom prst="roundRect">
-            <a:avLst>
-              <a:gd name="adj" fmla="val 6635"/>
-            </a:avLst>
-          </a:prstGeom>
-          <a:solidFill>
-            <a:srgbClr val="7FB927"/>
-          </a:solidFill>
-          <a:effectLst/>
-          <a:ln>
-            <a:noFill/>
-          </a:ln>
-          <a:effectLst>
-            <a:outerShdw blurRad="203200" dist="25400" dir="5400000" algn="ctr" rotWithShape="0">
-              <a:srgbClr val="003040">
-                <a:alpha val="6000"/>
-              </a:srgbClr>
-            </a:outerShdw>
-          </a:effectLst>
-        </p:spPr>
-        <p:style>
-          <a:lnRef idx="1">
-            <a:schemeClr val="accent1"/>
-          </a:lnRef>
-          <a:fillRef idx="3">
-            <a:schemeClr val="accent1"/>
-          </a:fillRef>
-          <a:effectRef idx="2">
-            <a:schemeClr val="accent1"/>
-          </a:effectRef>
-          <a:fontRef idx="minor">
-            <a:schemeClr val="lt1"/>
-          </a:fontRef>
-        </p:style>
-        <p:txBody>
-          <a:bodyPr rtlCol="0" anchor="ctr"/>
-          <a:lstStyle/>
-          <a:p/>
-        </p:txBody>
-      </p:sp>
-      <p:sp>
-        <p:nvSpPr>
-          <p:cNvPr id="28" name="Rounded Rectangle 27"/>
-          <p:cNvSpPr/>
-          <p:nvPr/>
-        </p:nvSpPr>
-        <p:spPr>
-          <a:xfrm>
-            <a:off x="1397000" y="5009753"/>
-            <a:ext cx="13462000" cy="2628900"/>
-          </a:xfrm>
-          <a:prstGeom prst="roundRect">
-            <a:avLst>
-              <a:gd name="adj" fmla="val 6763"/>
-            </a:avLst>
-          </a:prstGeom>
-          <a:solidFill>
-            <a:srgbClr val="ECF0F3"/>
-          </a:solidFill>
-          <a:effectLst/>
-          <a:ln>
-            <a:noFill/>
-          </a:ln>
-        </p:spPr>
-        <p:style>
-          <a:lnRef idx="1">
-            <a:schemeClr val="accent1"/>
-          </a:lnRef>
-          <a:fillRef idx="3">
-            <a:schemeClr val="accent1"/>
-          </a:fillRef>
-          <a:effectRef idx="2">
-            <a:schemeClr val="accent1"/>
-          </a:effectRef>
-          <a:fontRef idx="minor">
-            <a:schemeClr val="lt1"/>
-          </a:fontRef>
-        </p:style>
-        <p:txBody>
-          <a:bodyPr rtlCol="0" anchor="ctr"/>
-          <a:lstStyle/>
-          <a:p/>
-        </p:txBody>
-      </p:sp>
-      <p:sp>
-        <p:nvSpPr>
-          <p:cNvPr id="29" name="TextBox 28"/>
-          <p:cNvSpPr txBox="1"/>
-          <p:nvPr/>
-        </p:nvSpPr>
-        <p:spPr>
-          <a:xfrm>
-            <a:off x="1905000" y="5679678"/>
-            <a:ext cx="3576836" cy="355600"/>
-          </a:xfrm>
-          <a:prstGeom prst="rect">
-            <a:avLst/>
-          </a:prstGeom>
-          <a:noFill/>
-        </p:spPr>
-        <p:txBody>
-          <a:bodyPr wrap="none" lIns="0" rIns="0" tIns="0" bIns="0" anchor="t"/>
-          <a:lstStyle/>
-          <a:p>
-            <a:pPr algn="l">
-              <a:lnSpc>
-                <a:spcPct val="120000"/>
-              </a:lnSpc>
-            </a:pPr>
-            <a:r>
-              <a:rPr sz="2400" b="1" i="0">
-                <a:solidFill>
-                  <a:srgbClr val="003040"/>
-                </a:solidFill>
-                <a:latin typeface="Roboto"/>
-              </a:rPr>
-              <a:t>Gestiona integrat</a:t>
-            </a:r>
-          </a:p>
-        </p:txBody>
-      </p:sp>
-      <p:sp>
-        <p:nvSpPr>
-          <p:cNvPr id="30" name="TextBox 29"/>
-          <p:cNvSpPr txBox="1"/>
-          <p:nvPr/>
-        </p:nvSpPr>
-        <p:spPr>
-          <a:xfrm>
-            <a:off x="1905000" y="6162278"/>
-            <a:ext cx="3526036" cy="857250"/>
-          </a:xfrm>
-          <a:prstGeom prst="rect">
-            <a:avLst/>
-          </a:prstGeom>
-          <a:noFill/>
-        </p:spPr>
-        <p:txBody>
-          <a:bodyPr wrap="square" lIns="0" rIns="0" tIns="0" bIns="0" anchor="t"/>
-          <a:lstStyle/>
-          <a:p>
-            <a:pPr algn="l">
-              <a:lnSpc>
-                <a:spcPct val="150000"/>
-              </a:lnSpc>
-            </a:pPr>
-            <a:r>
-              <a:rPr sz="1500" b="0" i="0">
-                <a:solidFill>
-                  <a:srgbClr val="3D5C66"/>
-                </a:solidFill>
-                <a:latin typeface="Roboto"/>
-              </a:rPr>
-              <a:t>Condicionem la data d'arrencada al desenvolupament d'un projecte de Gestiona integrat.</a:t>
-            </a:r>
-          </a:p>
-        </p:txBody>
-      </p:sp>
-      <p:sp>
-        <p:nvSpPr>
-          <p:cNvPr id="31" name="TextBox 30"/>
-          <p:cNvSpPr txBox="1"/>
-          <p:nvPr/>
-        </p:nvSpPr>
-        <p:spPr>
-          <a:xfrm>
-            <a:off x="6015236" y="5806083"/>
-            <a:ext cx="3251200" cy="731441"/>
-          </a:xfrm>
-          <a:prstGeom prst="rect">
-            <a:avLst/>
-          </a:prstGeom>
-          <a:noFill/>
-        </p:spPr>
-        <p:txBody>
-          <a:bodyPr wrap="none" lIns="0" rIns="0" tIns="0" bIns="0" anchor="t"/>
-          <a:lstStyle/>
-          <a:p>
-            <a:pPr algn="l">
-              <a:lnSpc>
-                <a:spcPct val="100000"/>
-              </a:lnSpc>
-            </a:pPr>
-            <a:r>
-              <a:rPr sz="5760" b="1" i="0">
-                <a:solidFill>
-                  <a:srgbClr val="7FB927"/>
-                </a:solidFill>
-                <a:latin typeface="Roboto"/>
-              </a:rPr>
-              <a:t>3T 2027</a:t>
-            </a:r>
-          </a:p>
-        </p:txBody>
-      </p:sp>
-      <p:sp>
-        <p:nvSpPr>
-          <p:cNvPr id="32" name="TextBox 31"/>
-          <p:cNvSpPr txBox="1"/>
-          <p:nvPr/>
-        </p:nvSpPr>
-        <p:spPr>
-          <a:xfrm>
-            <a:off x="6015236" y="6613723"/>
-            <a:ext cx="3251200" cy="228600"/>
-          </a:xfrm>
-          <a:prstGeom prst="rect">
-            <a:avLst/>
-          </a:prstGeom>
-          <a:noFill/>
-        </p:spPr>
-        <p:txBody>
-          <a:bodyPr wrap="none" lIns="0" rIns="0" tIns="0" bIns="0" anchor="t"/>
-          <a:lstStyle/>
-          <a:p>
-            <a:pPr algn="l">
-              <a:lnSpc>
-                <a:spcPct val="120000"/>
-              </a:lnSpc>
-            </a:pPr>
-            <a:r>
-              <a:rPr sz="1520" b="0" i="0">
-                <a:solidFill>
-                  <a:srgbClr val="3D5C66"/>
-                </a:solidFill>
-                <a:latin typeface="Roboto"/>
-              </a:rPr>
-              <a:t>Arrencada · 17 de setembre de 2027</a:t>
-            </a:r>
-          </a:p>
-        </p:txBody>
-      </p:sp>
-      <p:sp>
-        <p:nvSpPr>
-          <p:cNvPr id="33" name="TextBox 32"/>
-          <p:cNvSpPr txBox="1"/>
-          <p:nvPr/>
-        </p:nvSpPr>
-        <p:spPr>
-          <a:xfrm>
-            <a:off x="9799836" y="5466953"/>
-            <a:ext cx="1437084" cy="228600"/>
-          </a:xfrm>
-          <a:prstGeom prst="rect">
-            <a:avLst/>
-          </a:prstGeom>
-          <a:noFill/>
-        </p:spPr>
-        <p:txBody>
-          <a:bodyPr wrap="none" lIns="0" rIns="0" tIns="0" bIns="0" anchor="t"/>
-          <a:lstStyle/>
-          <a:p>
-            <a:pPr algn="l">
-              <a:lnSpc>
-                <a:spcPct val="120000"/>
-              </a:lnSpc>
-            </a:pPr>
-            <a:r>
-              <a:rPr sz="1472" b="0" i="0">
-                <a:solidFill>
-                  <a:srgbClr val="3D5C66"/>
-                </a:solidFill>
-                <a:latin typeface="Roboto"/>
-              </a:rPr>
-              <a:t>Inici del projecte</a:t>
-            </a:r>
-          </a:p>
-        </p:txBody>
-      </p:sp>
-      <p:sp>
-        <p:nvSpPr>
-          <p:cNvPr id="34" name="TextBox 33"/>
-          <p:cNvSpPr txBox="1"/>
-          <p:nvPr/>
-        </p:nvSpPr>
-        <p:spPr>
-          <a:xfrm>
-            <a:off x="13305433" y="5466953"/>
-            <a:ext cx="1045567" cy="228600"/>
-          </a:xfrm>
-          <a:prstGeom prst="rect">
-            <a:avLst/>
-          </a:prstGeom>
-          <a:noFill/>
-        </p:spPr>
-        <p:txBody>
-          <a:bodyPr wrap="none" lIns="0" rIns="0" tIns="0" bIns="0" anchor="t"/>
-          <a:lstStyle/>
-          <a:p>
-            <a:pPr algn="r">
-              <a:lnSpc>
-                <a:spcPct val="120000"/>
-              </a:lnSpc>
-            </a:pPr>
-            <a:r>
-              <a:rPr sz="1472" b="0" i="0">
-                <a:solidFill>
-                  <a:srgbClr val="003040"/>
-                </a:solidFill>
-                <a:latin typeface="Roboto"/>
-              </a:rPr>
-              <a:t>Gener 2027</a:t>
-            </a:r>
-          </a:p>
-        </p:txBody>
-      </p:sp>
-      <p:sp>
-        <p:nvSpPr>
-          <p:cNvPr id="35" name="Rectangle 34"/>
-          <p:cNvSpPr/>
-          <p:nvPr/>
-        </p:nvSpPr>
-        <p:spPr>
-          <a:xfrm>
-            <a:off x="9799836" y="5822553"/>
-            <a:ext cx="4551164" cy="495300"/>
-          </a:xfrm>
-          <a:prstGeom prst="rect">
-            <a:avLst/>
-          </a:prstGeom>
-          <a:noFill/>
-          <a:effectLst/>
-          <a:ln>
-            <a:noFill/>
-          </a:ln>
-        </p:spPr>
-        <p:style>
-          <a:lnRef idx="1">
-            <a:schemeClr val="accent1"/>
-          </a:lnRef>
-          <a:fillRef idx="3">
-            <a:schemeClr val="accent1"/>
-          </a:fillRef>
-          <a:effectRef idx="2">
-            <a:schemeClr val="accent1"/>
-          </a:effectRef>
-          <a:fontRef idx="minor">
-            <a:schemeClr val="lt1"/>
-          </a:fontRef>
-        </p:style>
-        <p:txBody>
-          <a:bodyPr rtlCol="0" anchor="ctr"/>
-          <a:lstStyle/>
-          <a:p/>
-        </p:txBody>
-      </p:sp>
-      <p:sp>
-        <p:nvSpPr>
-          <p:cNvPr id="36" name="Rectangle 35"/>
-          <p:cNvSpPr/>
-          <p:nvPr/>
-        </p:nvSpPr>
-        <p:spPr>
-          <a:xfrm>
-            <a:off x="9799836" y="5822553"/>
-            <a:ext cx="4551164" cy="12700"/>
-          </a:xfrm>
-          <a:prstGeom prst="rect">
-            <a:avLst/>
-          </a:prstGeom>
-          <a:solidFill>
-            <a:srgbClr val="D4DEE3"/>
-          </a:solidFill>
-          <a:effectLst/>
-          <a:ln>
-            <a:noFill/>
-          </a:ln>
-        </p:spPr>
-        <p:style>
-          <a:lnRef idx="1">
-            <a:schemeClr val="accent1"/>
-          </a:lnRef>
-          <a:fillRef idx="3">
-            <a:schemeClr val="accent1"/>
-          </a:fillRef>
-          <a:effectRef idx="2">
-            <a:schemeClr val="accent1"/>
-          </a:effectRef>
-          <a:fontRef idx="minor">
-            <a:schemeClr val="lt1"/>
-          </a:fontRef>
-        </p:style>
-        <p:txBody>
-          <a:bodyPr rtlCol="0" anchor="ctr"/>
-          <a:lstStyle/>
-          <a:p/>
-        </p:txBody>
-      </p:sp>
-      <p:sp>
-        <p:nvSpPr>
-          <p:cNvPr id="37" name="TextBox 36"/>
-          <p:cNvSpPr txBox="1"/>
-          <p:nvPr/>
-        </p:nvSpPr>
-        <p:spPr>
-          <a:xfrm>
-            <a:off x="9799836" y="5962253"/>
-            <a:ext cx="1887141" cy="228600"/>
-          </a:xfrm>
-          <a:prstGeom prst="rect">
-            <a:avLst/>
-          </a:prstGeom>
-          <a:noFill/>
-        </p:spPr>
-        <p:txBody>
-          <a:bodyPr wrap="none" lIns="0" rIns="0" tIns="0" bIns="0" anchor="t"/>
-          <a:lstStyle/>
-          <a:p>
-            <a:pPr algn="l">
-              <a:lnSpc>
-                <a:spcPct val="120000"/>
-              </a:lnSpc>
-            </a:pPr>
-            <a:r>
-              <a:rPr sz="1472" b="0" i="0">
-                <a:solidFill>
-                  <a:srgbClr val="3D5C66"/>
-                </a:solidFill>
-                <a:latin typeface="Roboto"/>
-              </a:rPr>
-              <a:t>Migració d'expedients</a:t>
-            </a:r>
-          </a:p>
-        </p:txBody>
-      </p:sp>
-      <p:sp>
-        <p:nvSpPr>
-          <p:cNvPr id="38" name="TextBox 37"/>
-          <p:cNvSpPr txBox="1"/>
-          <p:nvPr/>
-        </p:nvSpPr>
-        <p:spPr>
-          <a:xfrm>
-            <a:off x="12249150" y="5962253"/>
-            <a:ext cx="2101850" cy="228600"/>
-          </a:xfrm>
-          <a:prstGeom prst="rect">
-            <a:avLst/>
-          </a:prstGeom>
-          <a:noFill/>
-        </p:spPr>
-        <p:txBody>
-          <a:bodyPr wrap="none" lIns="0" rIns="0" tIns="0" bIns="0" anchor="t"/>
-          <a:lstStyle/>
-          <a:p>
-            <a:pPr algn="r">
-              <a:lnSpc>
-                <a:spcPct val="120000"/>
-              </a:lnSpc>
-            </a:pPr>
-            <a:r>
-              <a:rPr sz="1472" b="0" i="0">
-                <a:solidFill>
-                  <a:srgbClr val="003040"/>
-                </a:solidFill>
-                <a:latin typeface="Roboto"/>
-              </a:rPr>
-              <a:t>17 de setembre de 2027</a:t>
-            </a:r>
-          </a:p>
-        </p:txBody>
-      </p:sp>
-      <p:sp>
-        <p:nvSpPr>
-          <p:cNvPr id="39" name="Rectangle 38"/>
-          <p:cNvSpPr/>
-          <p:nvPr/>
-        </p:nvSpPr>
-        <p:spPr>
-          <a:xfrm>
-            <a:off x="9799836" y="6317853"/>
-            <a:ext cx="4551164" cy="495300"/>
-          </a:xfrm>
-          <a:prstGeom prst="rect">
-            <a:avLst/>
-          </a:prstGeom>
-          <a:noFill/>
-          <a:effectLst/>
-          <a:ln>
-            <a:noFill/>
-          </a:ln>
-        </p:spPr>
-        <p:style>
-          <a:lnRef idx="1">
-            <a:schemeClr val="accent1"/>
-          </a:lnRef>
-          <a:fillRef idx="3">
-            <a:schemeClr val="accent1"/>
-          </a:fillRef>
-          <a:effectRef idx="2">
-            <a:schemeClr val="accent1"/>
-          </a:effectRef>
-          <a:fontRef idx="minor">
-            <a:schemeClr val="lt1"/>
-          </a:fontRef>
-        </p:style>
-        <p:txBody>
-          <a:bodyPr rtlCol="0" anchor="ctr"/>
-          <a:lstStyle/>
-          <a:p/>
-        </p:txBody>
-      </p:sp>
-      <p:sp>
-        <p:nvSpPr>
-          <p:cNvPr id="40" name="Rectangle 39"/>
-          <p:cNvSpPr/>
-          <p:nvPr/>
-        </p:nvSpPr>
-        <p:spPr>
-          <a:xfrm>
-            <a:off x="9799836" y="6317853"/>
-            <a:ext cx="4551164" cy="12700"/>
-          </a:xfrm>
-          <a:prstGeom prst="rect">
-            <a:avLst/>
-          </a:prstGeom>
-          <a:solidFill>
-            <a:srgbClr val="D4DEE3"/>
-          </a:solidFill>
-          <a:effectLst/>
-          <a:ln>
-            <a:noFill/>
-          </a:ln>
-        </p:spPr>
-        <p:style>
-          <a:lnRef idx="1">
-            <a:schemeClr val="accent1"/>
-          </a:lnRef>
-          <a:fillRef idx="3">
-            <a:schemeClr val="accent1"/>
-          </a:fillRef>
-          <a:effectRef idx="2">
-            <a:schemeClr val="accent1"/>
-          </a:effectRef>
-          <a:fontRef idx="minor">
-            <a:schemeClr val="lt1"/>
-          </a:fontRef>
-        </p:style>
-        <p:txBody>
-          <a:bodyPr rtlCol="0" anchor="ctr"/>
-          <a:lstStyle/>
-          <a:p/>
-        </p:txBody>
-      </p:sp>
-      <p:sp>
-        <p:nvSpPr>
-          <p:cNvPr id="41" name="TextBox 40"/>
-          <p:cNvSpPr txBox="1"/>
-          <p:nvPr/>
-        </p:nvSpPr>
-        <p:spPr>
-          <a:xfrm>
-            <a:off x="9799836" y="6457553"/>
-            <a:ext cx="1867694" cy="228600"/>
-          </a:xfrm>
-          <a:prstGeom prst="rect">
-            <a:avLst/>
-          </a:prstGeom>
-          <a:noFill/>
-        </p:spPr>
-        <p:txBody>
-          <a:bodyPr wrap="none" lIns="0" rIns="0" tIns="0" bIns="0" anchor="t"/>
-          <a:lstStyle/>
-          <a:p>
-            <a:pPr algn="l">
-              <a:lnSpc>
-                <a:spcPct val="120000"/>
-              </a:lnSpc>
-            </a:pPr>
-            <a:r>
-              <a:rPr sz="1472" b="0" i="0">
-                <a:solidFill>
-                  <a:srgbClr val="3D5C66"/>
-                </a:solidFill>
-                <a:latin typeface="Roboto"/>
-              </a:rPr>
-              <a:t>Evolutius de producte</a:t>
-            </a:r>
-          </a:p>
-        </p:txBody>
-      </p:sp>
-      <p:sp>
-        <p:nvSpPr>
-          <p:cNvPr id="42" name="TextBox 41"/>
-          <p:cNvSpPr txBox="1"/>
-          <p:nvPr/>
-        </p:nvSpPr>
-        <p:spPr>
-          <a:xfrm>
-            <a:off x="12249150" y="6457553"/>
-            <a:ext cx="2101850" cy="228600"/>
-          </a:xfrm>
-          <a:prstGeom prst="rect">
-            <a:avLst/>
-          </a:prstGeom>
-          <a:noFill/>
-        </p:spPr>
-        <p:txBody>
-          <a:bodyPr wrap="none" lIns="0" rIns="0" tIns="0" bIns="0" anchor="t"/>
-          <a:lstStyle/>
-          <a:p>
-            <a:pPr algn="r">
-              <a:lnSpc>
-                <a:spcPct val="120000"/>
-              </a:lnSpc>
-            </a:pPr>
-            <a:r>
-              <a:rPr sz="1472" b="0" i="0">
-                <a:solidFill>
-                  <a:srgbClr val="003040"/>
-                </a:solidFill>
-                <a:latin typeface="Roboto"/>
-              </a:rPr>
-              <a:t>17 de setembre de 2027</a:t>
-            </a:r>
-          </a:p>
-        </p:txBody>
-      </p:sp>
-      <p:sp>
-        <p:nvSpPr>
-          <p:cNvPr id="43" name="Rectangle 42"/>
-          <p:cNvSpPr/>
-          <p:nvPr/>
-        </p:nvSpPr>
-        <p:spPr>
-          <a:xfrm>
-            <a:off x="9799836" y="6813153"/>
-            <a:ext cx="4551164" cy="495300"/>
-          </a:xfrm>
-          <a:prstGeom prst="rect">
-            <a:avLst/>
-          </a:prstGeom>
-          <a:noFill/>
-          <a:effectLst/>
-          <a:ln>
-            <a:noFill/>
-          </a:ln>
-        </p:spPr>
-        <p:style>
-          <a:lnRef idx="1">
-            <a:schemeClr val="accent1"/>
-          </a:lnRef>
-          <a:fillRef idx="3">
-            <a:schemeClr val="accent1"/>
-          </a:fillRef>
-          <a:effectRef idx="2">
-            <a:schemeClr val="accent1"/>
-          </a:effectRef>
-          <a:fontRef idx="minor">
-            <a:schemeClr val="lt1"/>
-          </a:fontRef>
-        </p:style>
-        <p:txBody>
-          <a:bodyPr rtlCol="0" anchor="ctr"/>
-          <a:lstStyle/>
-          <a:p/>
-        </p:txBody>
-      </p:sp>
-      <p:sp>
-        <p:nvSpPr>
-          <p:cNvPr id="44" name="Rectangle 43"/>
-          <p:cNvSpPr/>
-          <p:nvPr/>
-        </p:nvSpPr>
-        <p:spPr>
-          <a:xfrm>
-            <a:off x="9799836" y="6813153"/>
-            <a:ext cx="4551164" cy="12700"/>
-          </a:xfrm>
-          <a:prstGeom prst="rect">
-            <a:avLst/>
-          </a:prstGeom>
-          <a:solidFill>
-            <a:srgbClr val="D4DEE3"/>
-          </a:solidFill>
-          <a:effectLst/>
-          <a:ln>
-            <a:noFill/>
-          </a:ln>
-        </p:spPr>
-        <p:style>
-          <a:lnRef idx="1">
-            <a:schemeClr val="accent1"/>
-          </a:lnRef>
-          <a:fillRef idx="3">
-            <a:schemeClr val="accent1"/>
-          </a:fillRef>
-          <a:effectRef idx="2">
-            <a:schemeClr val="accent1"/>
-          </a:effectRef>
-          <a:fontRef idx="minor">
-            <a:schemeClr val="lt1"/>
-          </a:fontRef>
-        </p:style>
-        <p:txBody>
-          <a:bodyPr rtlCol="0" anchor="ctr"/>
-          <a:lstStyle/>
-          <a:p/>
-        </p:txBody>
-      </p:sp>
-      <p:sp>
-        <p:nvSpPr>
-          <p:cNvPr id="45" name="TextBox 44"/>
-          <p:cNvSpPr txBox="1"/>
-          <p:nvPr/>
-        </p:nvSpPr>
-        <p:spPr>
-          <a:xfrm>
-            <a:off x="9799836" y="6952853"/>
-            <a:ext cx="2217341" cy="228600"/>
-          </a:xfrm>
-          <a:prstGeom prst="rect">
-            <a:avLst/>
-          </a:prstGeom>
-          <a:noFill/>
-        </p:spPr>
-        <p:txBody>
-          <a:bodyPr wrap="none" lIns="0" rIns="0" tIns="0" bIns="0" anchor="t"/>
-          <a:lstStyle/>
-          <a:p>
-            <a:pPr algn="l">
-              <a:lnSpc>
-                <a:spcPct val="120000"/>
-              </a:lnSpc>
-            </a:pPr>
-            <a:r>
-              <a:rPr sz="1472" b="0" i="0">
-                <a:solidFill>
-                  <a:srgbClr val="3D5C66"/>
-                </a:solidFill>
-                <a:latin typeface="Roboto"/>
-              </a:rPr>
-              <a:t>Projecte Gestiona Factory</a:t>
-            </a:r>
-          </a:p>
-        </p:txBody>
-      </p:sp>
-      <p:sp>
-        <p:nvSpPr>
-          <p:cNvPr id="46" name="TextBox 45"/>
-          <p:cNvSpPr txBox="1"/>
-          <p:nvPr/>
-        </p:nvSpPr>
-        <p:spPr>
-          <a:xfrm>
-            <a:off x="12301141" y="6952853"/>
-            <a:ext cx="2049859" cy="228600"/>
-          </a:xfrm>
-          <a:prstGeom prst="rect">
-            <a:avLst/>
-          </a:prstGeom>
-          <a:noFill/>
-        </p:spPr>
-        <p:txBody>
-          <a:bodyPr wrap="none" lIns="0" rIns="0" tIns="0" bIns="0" anchor="t"/>
-          <a:lstStyle/>
-          <a:p>
-            <a:pPr algn="r">
-              <a:lnSpc>
-                <a:spcPct val="120000"/>
-              </a:lnSpc>
-            </a:pPr>
-            <a:r>
-              <a:rPr sz="1472" b="0" i="0">
-                <a:solidFill>
-                  <a:srgbClr val="003040"/>
-                </a:solidFill>
-                <a:latin typeface="Roboto"/>
-              </a:rPr>
-              <a:t>Gener – setembre 2027</a:t>
-            </a:r>
-          </a:p>
-        </p:txBody>
-      </p:sp>
-      <p:sp>
-        <p:nvSpPr>
-          <p:cNvPr id="47" name="TextBox 46"/>
-          <p:cNvSpPr txBox="1"/>
-          <p:nvPr/>
-        </p:nvSpPr>
-        <p:spPr>
-          <a:xfrm>
-            <a:off x="1397000" y="7841853"/>
+      <p:grpSp>
+        <p:nvGrpSpPr>
+          <p:cNvPr id="7" name="Fase 1"/>
+          <p:cNvGrpSpPr/>
+          <p:nvPr/>
+        </p:nvGrpSpPr>
+        <p:grpSpPr>
+          <a:xfrm>
+            <a:off x="1397000" y="1829395"/>
+            <a:ext cx="6502400" cy="6005116"/>
+            <a:chOff x="1397000" y="1829395"/>
+            <a:chExt cx="6502400" cy="6005116"/>
+          </a:xfrm>
+        </p:grpSpPr>
+        <p:sp>
+          <p:nvSpPr>
+            <p:cNvPr id="8" name="Rounded Rectangle 7"/>
+            <p:cNvSpPr/>
+            <p:nvPr/>
+          </p:nvSpPr>
+          <p:spPr>
+            <a:xfrm>
+              <a:off x="1397000" y="1829395"/>
+              <a:ext cx="6502400" cy="6005116"/>
+            </a:xfrm>
+            <a:prstGeom prst="roundRect">
+              <a:avLst>
+                <a:gd name="adj" fmla="val 2960"/>
+              </a:avLst>
+            </a:prstGeom>
+            <a:solidFill>
+              <a:srgbClr val="7FB927"/>
+            </a:solidFill>
+            <a:effectLst/>
+            <a:ln>
+              <a:noFill/>
+            </a:ln>
+            <a:effectLst>
+              <a:outerShdw blurRad="203200" dist="25400" dir="5400000" algn="ctr" rotWithShape="0">
+                <a:srgbClr val="003040">
+                  <a:alpha val="6000"/>
+                </a:srgbClr>
+              </a:outerShdw>
+            </a:effectLst>
+          </p:spPr>
+          <p:style>
+            <a:lnRef idx="1">
+              <a:schemeClr val="accent1"/>
+            </a:lnRef>
+            <a:fillRef idx="3">
+              <a:schemeClr val="accent1"/>
+            </a:fillRef>
+            <a:effectRef idx="2">
+              <a:schemeClr val="accent1"/>
+            </a:effectRef>
+            <a:fontRef idx="minor">
+              <a:schemeClr val="lt1"/>
+            </a:fontRef>
+          </p:style>
+          <p:txBody>
+            <a:bodyPr rtlCol="0" anchor="ctr"/>
+            <a:lstStyle/>
+            <a:p/>
+          </p:txBody>
+        </p:sp>
+        <p:sp>
+          <p:nvSpPr>
+            <p:cNvPr id="9" name="Rounded Rectangle 8"/>
+            <p:cNvSpPr/>
+            <p:nvPr/>
+          </p:nvSpPr>
+          <p:spPr>
+            <a:xfrm>
+              <a:off x="1397000" y="1880195"/>
+              <a:ext cx="6502400" cy="5954316"/>
+            </a:xfrm>
+            <a:prstGeom prst="roundRect">
+              <a:avLst>
+                <a:gd name="adj" fmla="val 2986"/>
+              </a:avLst>
+            </a:prstGeom>
+            <a:solidFill>
+              <a:srgbClr val="ECF0F3"/>
+            </a:solidFill>
+            <a:effectLst/>
+            <a:ln>
+              <a:noFill/>
+            </a:ln>
+          </p:spPr>
+          <p:style>
+            <a:lnRef idx="1">
+              <a:schemeClr val="accent1"/>
+            </a:lnRef>
+            <a:fillRef idx="3">
+              <a:schemeClr val="accent1"/>
+            </a:fillRef>
+            <a:effectRef idx="2">
+              <a:schemeClr val="accent1"/>
+            </a:effectRef>
+            <a:fontRef idx="minor">
+              <a:schemeClr val="lt1"/>
+            </a:fontRef>
+          </p:style>
+          <p:txBody>
+            <a:bodyPr rtlCol="0" anchor="ctr"/>
+            <a:lstStyle/>
+            <a:p/>
+          </p:txBody>
+        </p:sp>
+        <p:sp>
+          <p:nvSpPr>
+            <p:cNvPr id="10" name="TextBox 9"/>
+            <p:cNvSpPr txBox="1"/>
+            <p:nvPr/>
+          </p:nvSpPr>
+          <p:spPr>
+            <a:xfrm>
+              <a:off x="1905000" y="2388195"/>
+              <a:ext cx="5562600" cy="355600"/>
+            </a:xfrm>
+            <a:prstGeom prst="rect">
+              <a:avLst/>
+            </a:prstGeom>
+            <a:noFill/>
+          </p:spPr>
+          <p:txBody>
+            <a:bodyPr wrap="none" lIns="0" rIns="0" tIns="0" bIns="0" anchor="t"/>
+            <a:lstStyle/>
+            <a:p>
+              <a:pPr algn="l">
+                <a:lnSpc>
+                  <a:spcPct val="120000"/>
+                </a:lnSpc>
+              </a:pPr>
+              <a:r>
+                <a:rPr sz="2400" b="1" i="0">
+                  <a:solidFill>
+                    <a:srgbClr val="003040"/>
+                  </a:solidFill>
+                  <a:latin typeface="Roboto"/>
+                </a:rPr>
+                <a:t>Gestiona + Anexa</a:t>
+              </a:r>
+            </a:p>
+          </p:txBody>
+        </p:sp>
+        <p:sp>
+          <p:nvSpPr>
+            <p:cNvPr id="11" name="TextBox 10"/>
+            <p:cNvSpPr txBox="1"/>
+            <p:nvPr/>
+          </p:nvSpPr>
+          <p:spPr>
+            <a:xfrm>
+              <a:off x="1905000" y="2870795"/>
+              <a:ext cx="5511800" cy="828675"/>
+            </a:xfrm>
+            <a:prstGeom prst="rect">
+              <a:avLst/>
+            </a:prstGeom>
+            <a:noFill/>
+          </p:spPr>
+          <p:txBody>
+            <a:bodyPr wrap="square" lIns="0" rIns="0" tIns="0" bIns="0" anchor="t"/>
+            <a:lstStyle/>
+            <a:p>
+              <a:pPr algn="l">
+                <a:lnSpc>
+                  <a:spcPct val="150000"/>
+                </a:lnSpc>
+              </a:pPr>
+              <a:r>
+                <a:rPr sz="1500" b="0" i="0">
+                  <a:solidFill>
+                    <a:srgbClr val="3D5C66"/>
+                  </a:solidFill>
+                  <a:latin typeface="Roboto"/>
+                </a:rPr>
+                <a:t>Traslladem la tramitació administrativa a Gestiona i mantenim algunes funcionalitats del projecte Factory a Anexa.</a:t>
+              </a:r>
+            </a:p>
+          </p:txBody>
+        </p:sp>
+        <p:sp>
+          <p:nvSpPr>
+            <p:cNvPr id="12" name="TextBox 11"/>
+            <p:cNvSpPr txBox="1"/>
+            <p:nvPr/>
+          </p:nvSpPr>
+          <p:spPr>
+            <a:xfrm>
+              <a:off x="1905000" y="4004270"/>
+              <a:ext cx="5562600" cy="731441"/>
+            </a:xfrm>
+            <a:prstGeom prst="rect">
+              <a:avLst/>
+            </a:prstGeom>
+            <a:noFill/>
+          </p:spPr>
+          <p:txBody>
+            <a:bodyPr wrap="none" lIns="0" rIns="0" tIns="0" bIns="0" anchor="t"/>
+            <a:lstStyle/>
+            <a:p>
+              <a:pPr algn="l">
+                <a:lnSpc>
+                  <a:spcPct val="100000"/>
+                </a:lnSpc>
+              </a:pPr>
+              <a:r>
+                <a:rPr sz="5760" b="1" i="0">
+                  <a:solidFill>
+                    <a:srgbClr val="7FB927"/>
+                  </a:solidFill>
+                  <a:latin typeface="Roboto"/>
+                </a:rPr>
+                <a:t>1T 2027</a:t>
+              </a:r>
+            </a:p>
+          </p:txBody>
+        </p:sp>
+        <p:sp>
+          <p:nvSpPr>
+            <p:cNvPr id="13" name="TextBox 12"/>
+            <p:cNvSpPr txBox="1"/>
+            <p:nvPr/>
+          </p:nvSpPr>
+          <p:spPr>
+            <a:xfrm>
+              <a:off x="1905000" y="4811911"/>
+              <a:ext cx="5562600" cy="228600"/>
+            </a:xfrm>
+            <a:prstGeom prst="rect">
+              <a:avLst/>
+            </a:prstGeom>
+            <a:noFill/>
+          </p:spPr>
+          <p:txBody>
+            <a:bodyPr wrap="none" lIns="0" rIns="0" tIns="0" bIns="0" anchor="t"/>
+            <a:lstStyle/>
+            <a:p>
+              <a:pPr algn="l">
+                <a:lnSpc>
+                  <a:spcPct val="120000"/>
+                </a:lnSpc>
+              </a:pPr>
+              <a:r>
+                <a:rPr sz="1520" b="0" i="0">
+                  <a:solidFill>
+                    <a:srgbClr val="3D5C66"/>
+                  </a:solidFill>
+                  <a:latin typeface="Roboto"/>
+                </a:rPr>
+                <a:t>Arrencada · 28 de febrer de 2027*</a:t>
+              </a:r>
+            </a:p>
+          </p:txBody>
+        </p:sp>
+        <p:sp>
+          <p:nvSpPr>
+            <p:cNvPr id="14" name="Rectangle 13"/>
+            <p:cNvSpPr/>
+            <p:nvPr/>
+          </p:nvSpPr>
+          <p:spPr>
+            <a:xfrm>
+              <a:off x="1905000" y="5396111"/>
+              <a:ext cx="5486400" cy="495300"/>
+            </a:xfrm>
+            <a:prstGeom prst="rect">
+              <a:avLst/>
+            </a:prstGeom>
+            <a:noFill/>
+            <a:effectLst/>
+            <a:ln>
+              <a:noFill/>
+            </a:ln>
+          </p:spPr>
+          <p:style>
+            <a:lnRef idx="1">
+              <a:schemeClr val="accent1"/>
+            </a:lnRef>
+            <a:fillRef idx="3">
+              <a:schemeClr val="accent1"/>
+            </a:fillRef>
+            <a:effectRef idx="2">
+              <a:schemeClr val="accent1"/>
+            </a:effectRef>
+            <a:fontRef idx="minor">
+              <a:schemeClr val="lt1"/>
+            </a:fontRef>
+          </p:style>
+          <p:txBody>
+            <a:bodyPr rtlCol="0" anchor="ctr"/>
+            <a:lstStyle/>
+            <a:p/>
+          </p:txBody>
+        </p:sp>
+        <p:sp>
+          <p:nvSpPr>
+            <p:cNvPr id="15" name="Rectangle 14"/>
+            <p:cNvSpPr/>
+            <p:nvPr/>
+          </p:nvSpPr>
+          <p:spPr>
+            <a:xfrm>
+              <a:off x="1905000" y="5396111"/>
+              <a:ext cx="5486400" cy="12700"/>
+            </a:xfrm>
+            <a:prstGeom prst="rect">
+              <a:avLst/>
+            </a:prstGeom>
+            <a:solidFill>
+              <a:srgbClr val="D4DEE3"/>
+            </a:solidFill>
+            <a:effectLst/>
+            <a:ln>
+              <a:noFill/>
+            </a:ln>
+          </p:spPr>
+          <p:style>
+            <a:lnRef idx="1">
+              <a:schemeClr val="accent1"/>
+            </a:lnRef>
+            <a:fillRef idx="3">
+              <a:schemeClr val="accent1"/>
+            </a:fillRef>
+            <a:effectRef idx="2">
+              <a:schemeClr val="accent1"/>
+            </a:effectRef>
+            <a:fontRef idx="minor">
+              <a:schemeClr val="lt1"/>
+            </a:fontRef>
+          </p:style>
+          <p:txBody>
+            <a:bodyPr rtlCol="0" anchor="ctr"/>
+            <a:lstStyle/>
+            <a:p/>
+          </p:txBody>
+        </p:sp>
+        <p:sp>
+          <p:nvSpPr>
+            <p:cNvPr id="16" name="TextBox 15"/>
+            <p:cNvSpPr txBox="1"/>
+            <p:nvPr/>
+          </p:nvSpPr>
+          <p:spPr>
+            <a:xfrm>
+              <a:off x="1905000" y="5535811"/>
+              <a:ext cx="1437084" cy="228600"/>
+            </a:xfrm>
+            <a:prstGeom prst="rect">
+              <a:avLst/>
+            </a:prstGeom>
+            <a:noFill/>
+          </p:spPr>
+          <p:txBody>
+            <a:bodyPr wrap="none" lIns="0" rIns="0" tIns="0" bIns="0" anchor="t"/>
+            <a:lstStyle/>
+            <a:p>
+              <a:pPr algn="l">
+                <a:lnSpc>
+                  <a:spcPct val="120000"/>
+                </a:lnSpc>
+              </a:pPr>
+              <a:r>
+                <a:rPr sz="1472" b="0" i="0">
+                  <a:solidFill>
+                    <a:srgbClr val="3D5C66"/>
+                  </a:solidFill>
+                  <a:latin typeface="Roboto"/>
+                </a:rPr>
+                <a:t>Inici del projecte</a:t>
+              </a:r>
+            </a:p>
+          </p:txBody>
+        </p:sp>
+        <p:sp>
+          <p:nvSpPr>
+            <p:cNvPr id="17" name="TextBox 16"/>
+            <p:cNvSpPr txBox="1"/>
+            <p:nvPr/>
+          </p:nvSpPr>
+          <p:spPr>
+            <a:xfrm>
+              <a:off x="5982097" y="5535811"/>
+              <a:ext cx="1409303" cy="228600"/>
+            </a:xfrm>
+            <a:prstGeom prst="rect">
+              <a:avLst/>
+            </a:prstGeom>
+            <a:noFill/>
+          </p:spPr>
+          <p:txBody>
+            <a:bodyPr wrap="none" lIns="0" rIns="0" tIns="0" bIns="0" anchor="t"/>
+            <a:lstStyle/>
+            <a:p>
+              <a:pPr algn="r">
+                <a:lnSpc>
+                  <a:spcPct val="120000"/>
+                </a:lnSpc>
+              </a:pPr>
+              <a:r>
+                <a:rPr sz="1472" b="0" i="0">
+                  <a:solidFill>
+                    <a:srgbClr val="003040"/>
+                  </a:solidFill>
+                  <a:latin typeface="Roboto"/>
+                </a:rPr>
+                <a:t>Novembre 2026</a:t>
+              </a:r>
+            </a:p>
+          </p:txBody>
+        </p:sp>
+        <p:sp>
+          <p:nvSpPr>
+            <p:cNvPr id="18" name="Rectangle 17"/>
+            <p:cNvSpPr/>
+            <p:nvPr/>
+          </p:nvSpPr>
+          <p:spPr>
+            <a:xfrm>
+              <a:off x="1905000" y="5891411"/>
+              <a:ext cx="5486400" cy="495300"/>
+            </a:xfrm>
+            <a:prstGeom prst="rect">
+              <a:avLst/>
+            </a:prstGeom>
+            <a:noFill/>
+            <a:effectLst/>
+            <a:ln>
+              <a:noFill/>
+            </a:ln>
+          </p:spPr>
+          <p:style>
+            <a:lnRef idx="1">
+              <a:schemeClr val="accent1"/>
+            </a:lnRef>
+            <a:fillRef idx="3">
+              <a:schemeClr val="accent1"/>
+            </a:fillRef>
+            <a:effectRef idx="2">
+              <a:schemeClr val="accent1"/>
+            </a:effectRef>
+            <a:fontRef idx="minor">
+              <a:schemeClr val="lt1"/>
+            </a:fontRef>
+          </p:style>
+          <p:txBody>
+            <a:bodyPr rtlCol="0" anchor="ctr"/>
+            <a:lstStyle/>
+            <a:p/>
+          </p:txBody>
+        </p:sp>
+        <p:sp>
+          <p:nvSpPr>
+            <p:cNvPr id="19" name="Rectangle 18"/>
+            <p:cNvSpPr/>
+            <p:nvPr/>
+          </p:nvSpPr>
+          <p:spPr>
+            <a:xfrm>
+              <a:off x="1905000" y="5891411"/>
+              <a:ext cx="5486400" cy="12700"/>
+            </a:xfrm>
+            <a:prstGeom prst="rect">
+              <a:avLst/>
+            </a:prstGeom>
+            <a:solidFill>
+              <a:srgbClr val="D4DEE3"/>
+            </a:solidFill>
+            <a:effectLst/>
+            <a:ln>
+              <a:noFill/>
+            </a:ln>
+          </p:spPr>
+          <p:style>
+            <a:lnRef idx="1">
+              <a:schemeClr val="accent1"/>
+            </a:lnRef>
+            <a:fillRef idx="3">
+              <a:schemeClr val="accent1"/>
+            </a:fillRef>
+            <a:effectRef idx="2">
+              <a:schemeClr val="accent1"/>
+            </a:effectRef>
+            <a:fontRef idx="minor">
+              <a:schemeClr val="lt1"/>
+            </a:fontRef>
+          </p:style>
+          <p:txBody>
+            <a:bodyPr rtlCol="0" anchor="ctr"/>
+            <a:lstStyle/>
+            <a:p/>
+          </p:txBody>
+        </p:sp>
+        <p:sp>
+          <p:nvSpPr>
+            <p:cNvPr id="20" name="TextBox 19"/>
+            <p:cNvSpPr txBox="1"/>
+            <p:nvPr/>
+          </p:nvSpPr>
+          <p:spPr>
+            <a:xfrm>
+              <a:off x="1905000" y="6031111"/>
+              <a:ext cx="2654895" cy="228600"/>
+            </a:xfrm>
+            <a:prstGeom prst="rect">
+              <a:avLst/>
+            </a:prstGeom>
+            <a:noFill/>
+          </p:spPr>
+          <p:txBody>
+            <a:bodyPr wrap="none" lIns="0" rIns="0" tIns="0" bIns="0" anchor="t"/>
+            <a:lstStyle/>
+            <a:p>
+              <a:pPr algn="l">
+                <a:lnSpc>
+                  <a:spcPct val="120000"/>
+                </a:lnSpc>
+              </a:pPr>
+              <a:r>
+                <a:rPr sz="1472" b="0" i="0">
+                  <a:solidFill>
+                    <a:srgbClr val="3D5C66"/>
+                  </a:solidFill>
+                  <a:latin typeface="Roboto"/>
+                </a:rPr>
+                <a:t>Migració d'expedients i registre</a:t>
+              </a:r>
+            </a:p>
+          </p:txBody>
+        </p:sp>
+        <p:sp>
+          <p:nvSpPr>
+            <p:cNvPr id="21" name="TextBox 20"/>
+            <p:cNvSpPr txBox="1"/>
+            <p:nvPr/>
+          </p:nvSpPr>
+          <p:spPr>
+            <a:xfrm>
+              <a:off x="5581055" y="6031111"/>
+              <a:ext cx="1810345" cy="228600"/>
+            </a:xfrm>
+            <a:prstGeom prst="rect">
+              <a:avLst/>
+            </a:prstGeom>
+            <a:noFill/>
+          </p:spPr>
+          <p:txBody>
+            <a:bodyPr wrap="none" lIns="0" rIns="0" tIns="0" bIns="0" anchor="t"/>
+            <a:lstStyle/>
+            <a:p>
+              <a:pPr algn="r">
+                <a:lnSpc>
+                  <a:spcPct val="120000"/>
+                </a:lnSpc>
+              </a:pPr>
+              <a:r>
+                <a:rPr sz="1472" b="0" i="0">
+                  <a:solidFill>
+                    <a:srgbClr val="003040"/>
+                  </a:solidFill>
+                  <a:latin typeface="Roboto"/>
+                </a:rPr>
+                <a:t>28 de febrer de 2027</a:t>
+              </a:r>
+            </a:p>
+          </p:txBody>
+        </p:sp>
+        <p:sp>
+          <p:nvSpPr>
+            <p:cNvPr id="22" name="Rectangle 21"/>
+            <p:cNvSpPr/>
+            <p:nvPr/>
+          </p:nvSpPr>
+          <p:spPr>
+            <a:xfrm>
+              <a:off x="1905000" y="6386711"/>
+              <a:ext cx="5486400" cy="495300"/>
+            </a:xfrm>
+            <a:prstGeom prst="rect">
+              <a:avLst/>
+            </a:prstGeom>
+            <a:noFill/>
+            <a:effectLst/>
+            <a:ln>
+              <a:noFill/>
+            </a:ln>
+          </p:spPr>
+          <p:style>
+            <a:lnRef idx="1">
+              <a:schemeClr val="accent1"/>
+            </a:lnRef>
+            <a:fillRef idx="3">
+              <a:schemeClr val="accent1"/>
+            </a:fillRef>
+            <a:effectRef idx="2">
+              <a:schemeClr val="accent1"/>
+            </a:effectRef>
+            <a:fontRef idx="minor">
+              <a:schemeClr val="lt1"/>
+            </a:fontRef>
+          </p:style>
+          <p:txBody>
+            <a:bodyPr rtlCol="0" anchor="ctr"/>
+            <a:lstStyle/>
+            <a:p/>
+          </p:txBody>
+        </p:sp>
+        <p:sp>
+          <p:nvSpPr>
+            <p:cNvPr id="23" name="Rectangle 22"/>
+            <p:cNvSpPr/>
+            <p:nvPr/>
+          </p:nvSpPr>
+          <p:spPr>
+            <a:xfrm>
+              <a:off x="1905000" y="6386711"/>
+              <a:ext cx="5486400" cy="12700"/>
+            </a:xfrm>
+            <a:prstGeom prst="rect">
+              <a:avLst/>
+            </a:prstGeom>
+            <a:solidFill>
+              <a:srgbClr val="D4DEE3"/>
+            </a:solidFill>
+            <a:effectLst/>
+            <a:ln>
+              <a:noFill/>
+            </a:ln>
+          </p:spPr>
+          <p:style>
+            <a:lnRef idx="1">
+              <a:schemeClr val="accent1"/>
+            </a:lnRef>
+            <a:fillRef idx="3">
+              <a:schemeClr val="accent1"/>
+            </a:fillRef>
+            <a:effectRef idx="2">
+              <a:schemeClr val="accent1"/>
+            </a:effectRef>
+            <a:fontRef idx="minor">
+              <a:schemeClr val="lt1"/>
+            </a:fontRef>
+          </p:style>
+          <p:txBody>
+            <a:bodyPr rtlCol="0" anchor="ctr"/>
+            <a:lstStyle/>
+            <a:p/>
+          </p:txBody>
+        </p:sp>
+        <p:sp>
+          <p:nvSpPr>
+            <p:cNvPr id="24" name="TextBox 23"/>
+            <p:cNvSpPr txBox="1"/>
+            <p:nvPr/>
+          </p:nvSpPr>
+          <p:spPr>
+            <a:xfrm>
+              <a:off x="1905000" y="6526411"/>
+              <a:ext cx="1867694" cy="228600"/>
+            </a:xfrm>
+            <a:prstGeom prst="rect">
+              <a:avLst/>
+            </a:prstGeom>
+            <a:noFill/>
+          </p:spPr>
+          <p:txBody>
+            <a:bodyPr wrap="none" lIns="0" rIns="0" tIns="0" bIns="0" anchor="t"/>
+            <a:lstStyle/>
+            <a:p>
+              <a:pPr algn="l">
+                <a:lnSpc>
+                  <a:spcPct val="120000"/>
+                </a:lnSpc>
+              </a:pPr>
+              <a:r>
+                <a:rPr sz="1472" b="0" i="0">
+                  <a:solidFill>
+                    <a:srgbClr val="3D5C66"/>
+                  </a:solidFill>
+                  <a:latin typeface="Roboto"/>
+                </a:rPr>
+                <a:t>Evolutius de producte</a:t>
+              </a:r>
+            </a:p>
+          </p:txBody>
+        </p:sp>
+        <p:sp>
+          <p:nvSpPr>
+            <p:cNvPr id="25" name="TextBox 24"/>
+            <p:cNvSpPr txBox="1"/>
+            <p:nvPr/>
+          </p:nvSpPr>
+          <p:spPr>
+            <a:xfrm>
+              <a:off x="5581055" y="6526411"/>
+              <a:ext cx="1810345" cy="228600"/>
+            </a:xfrm>
+            <a:prstGeom prst="rect">
+              <a:avLst/>
+            </a:prstGeom>
+            <a:noFill/>
+          </p:spPr>
+          <p:txBody>
+            <a:bodyPr wrap="none" lIns="0" rIns="0" tIns="0" bIns="0" anchor="t"/>
+            <a:lstStyle/>
+            <a:p>
+              <a:pPr algn="r">
+                <a:lnSpc>
+                  <a:spcPct val="120000"/>
+                </a:lnSpc>
+              </a:pPr>
+              <a:r>
+                <a:rPr sz="1472" b="0" i="0">
+                  <a:solidFill>
+                    <a:srgbClr val="003040"/>
+                  </a:solidFill>
+                  <a:latin typeface="Roboto"/>
+                </a:rPr>
+                <a:t>28 de febrer de 2027</a:t>
+              </a:r>
+            </a:p>
+          </p:txBody>
+        </p:sp>
+        <p:sp>
+          <p:nvSpPr>
+            <p:cNvPr id="26" name="Rectangle 25"/>
+            <p:cNvSpPr/>
+            <p:nvPr/>
+          </p:nvSpPr>
+          <p:spPr>
+            <a:xfrm>
+              <a:off x="1905000" y="6882011"/>
+              <a:ext cx="5486400" cy="495300"/>
+            </a:xfrm>
+            <a:prstGeom prst="rect">
+              <a:avLst/>
+            </a:prstGeom>
+            <a:noFill/>
+            <a:effectLst/>
+            <a:ln>
+              <a:noFill/>
+            </a:ln>
+          </p:spPr>
+          <p:style>
+            <a:lnRef idx="1">
+              <a:schemeClr val="accent1"/>
+            </a:lnRef>
+            <a:fillRef idx="3">
+              <a:schemeClr val="accent1"/>
+            </a:fillRef>
+            <a:effectRef idx="2">
+              <a:schemeClr val="accent1"/>
+            </a:effectRef>
+            <a:fontRef idx="minor">
+              <a:schemeClr val="lt1"/>
+            </a:fontRef>
+          </p:style>
+          <p:txBody>
+            <a:bodyPr rtlCol="0" anchor="ctr"/>
+            <a:lstStyle/>
+            <a:p/>
+          </p:txBody>
+        </p:sp>
+        <p:sp>
+          <p:nvSpPr>
+            <p:cNvPr id="27" name="Rectangle 26"/>
+            <p:cNvSpPr/>
+            <p:nvPr/>
+          </p:nvSpPr>
+          <p:spPr>
+            <a:xfrm>
+              <a:off x="1905000" y="6882011"/>
+              <a:ext cx="5486400" cy="12700"/>
+            </a:xfrm>
+            <a:prstGeom prst="rect">
+              <a:avLst/>
+            </a:prstGeom>
+            <a:solidFill>
+              <a:srgbClr val="D4DEE3"/>
+            </a:solidFill>
+            <a:effectLst/>
+            <a:ln>
+              <a:noFill/>
+            </a:ln>
+          </p:spPr>
+          <p:style>
+            <a:lnRef idx="1">
+              <a:schemeClr val="accent1"/>
+            </a:lnRef>
+            <a:fillRef idx="3">
+              <a:schemeClr val="accent1"/>
+            </a:fillRef>
+            <a:effectRef idx="2">
+              <a:schemeClr val="accent1"/>
+            </a:effectRef>
+            <a:fontRef idx="minor">
+              <a:schemeClr val="lt1"/>
+            </a:fontRef>
+          </p:style>
+          <p:txBody>
+            <a:bodyPr rtlCol="0" anchor="ctr"/>
+            <a:lstStyle/>
+            <a:p/>
+          </p:txBody>
+        </p:sp>
+        <p:sp>
+          <p:nvSpPr>
+            <p:cNvPr id="28" name="TextBox 27"/>
+            <p:cNvSpPr txBox="1"/>
+            <p:nvPr/>
+          </p:nvSpPr>
+          <p:spPr>
+            <a:xfrm>
+              <a:off x="1905000" y="7021711"/>
+              <a:ext cx="2217341" cy="228600"/>
+            </a:xfrm>
+            <a:prstGeom prst="rect">
+              <a:avLst/>
+            </a:prstGeom>
+            <a:noFill/>
+          </p:spPr>
+          <p:txBody>
+            <a:bodyPr wrap="none" lIns="0" rIns="0" tIns="0" bIns="0" anchor="t"/>
+            <a:lstStyle/>
+            <a:p>
+              <a:pPr algn="l">
+                <a:lnSpc>
+                  <a:spcPct val="120000"/>
+                </a:lnSpc>
+              </a:pPr>
+              <a:r>
+                <a:rPr sz="1472" b="0" i="0">
+                  <a:solidFill>
+                    <a:srgbClr val="3D5C66"/>
+                  </a:solidFill>
+                  <a:latin typeface="Roboto"/>
+                </a:rPr>
+                <a:t>Projecte Gestiona Factory</a:t>
+              </a:r>
+            </a:p>
+          </p:txBody>
+        </p:sp>
+        <p:sp>
+          <p:nvSpPr>
+            <p:cNvPr id="29" name="TextBox 28"/>
+            <p:cNvSpPr txBox="1"/>
+            <p:nvPr/>
+          </p:nvSpPr>
+          <p:spPr>
+            <a:xfrm>
+              <a:off x="5341541" y="7021711"/>
+              <a:ext cx="2049859" cy="228600"/>
+            </a:xfrm>
+            <a:prstGeom prst="rect">
+              <a:avLst/>
+            </a:prstGeom>
+            <a:noFill/>
+          </p:spPr>
+          <p:txBody>
+            <a:bodyPr wrap="none" lIns="0" rIns="0" tIns="0" bIns="0" anchor="t"/>
+            <a:lstStyle/>
+            <a:p>
+              <a:pPr algn="r">
+                <a:lnSpc>
+                  <a:spcPct val="120000"/>
+                </a:lnSpc>
+              </a:pPr>
+              <a:r>
+                <a:rPr sz="1472" b="0" i="0">
+                  <a:solidFill>
+                    <a:srgbClr val="003040"/>
+                  </a:solidFill>
+                  <a:latin typeface="Roboto"/>
+                </a:rPr>
+                <a:t>Gener – setembre 2027</a:t>
+              </a:r>
+            </a:p>
+          </p:txBody>
+        </p:sp>
+      </p:grpSp>
+      <p:grpSp>
+        <p:nvGrpSpPr>
+          <p:cNvPr id="30" name="Fase 2"/>
+          <p:cNvGrpSpPr/>
+          <p:nvPr/>
+        </p:nvGrpSpPr>
+        <p:grpSpPr>
+          <a:xfrm>
+            <a:off x="8356600" y="1829395"/>
+            <a:ext cx="6502400" cy="6005116"/>
+            <a:chOff x="8356600" y="1829395"/>
+            <a:chExt cx="6502400" cy="6005116"/>
+          </a:xfrm>
+        </p:grpSpPr>
+        <p:sp>
+          <p:nvSpPr>
+            <p:cNvPr id="31" name="Rounded Rectangle 30"/>
+            <p:cNvSpPr/>
+            <p:nvPr/>
+          </p:nvSpPr>
+          <p:spPr>
+            <a:xfrm>
+              <a:off x="8356600" y="1829395"/>
+              <a:ext cx="6502400" cy="6005116"/>
+            </a:xfrm>
+            <a:prstGeom prst="roundRect">
+              <a:avLst>
+                <a:gd name="adj" fmla="val 2960"/>
+              </a:avLst>
+            </a:prstGeom>
+            <a:solidFill>
+              <a:srgbClr val="7FB927"/>
+            </a:solidFill>
+            <a:effectLst/>
+            <a:ln>
+              <a:noFill/>
+            </a:ln>
+            <a:effectLst>
+              <a:outerShdw blurRad="203200" dist="25400" dir="5400000" algn="ctr" rotWithShape="0">
+                <a:srgbClr val="003040">
+                  <a:alpha val="6000"/>
+                </a:srgbClr>
+              </a:outerShdw>
+            </a:effectLst>
+          </p:spPr>
+          <p:style>
+            <a:lnRef idx="1">
+              <a:schemeClr val="accent1"/>
+            </a:lnRef>
+            <a:fillRef idx="3">
+              <a:schemeClr val="accent1"/>
+            </a:fillRef>
+            <a:effectRef idx="2">
+              <a:schemeClr val="accent1"/>
+            </a:effectRef>
+            <a:fontRef idx="minor">
+              <a:schemeClr val="lt1"/>
+            </a:fontRef>
+          </p:style>
+          <p:txBody>
+            <a:bodyPr rtlCol="0" anchor="ctr"/>
+            <a:lstStyle/>
+            <a:p/>
+          </p:txBody>
+        </p:sp>
+        <p:sp>
+          <p:nvSpPr>
+            <p:cNvPr id="32" name="Rounded Rectangle 31"/>
+            <p:cNvSpPr/>
+            <p:nvPr/>
+          </p:nvSpPr>
+          <p:spPr>
+            <a:xfrm>
+              <a:off x="8356600" y="1880195"/>
+              <a:ext cx="6502400" cy="5954316"/>
+            </a:xfrm>
+            <a:prstGeom prst="roundRect">
+              <a:avLst>
+                <a:gd name="adj" fmla="val 2986"/>
+              </a:avLst>
+            </a:prstGeom>
+            <a:solidFill>
+              <a:srgbClr val="ECF0F3"/>
+            </a:solidFill>
+            <a:effectLst/>
+            <a:ln>
+              <a:noFill/>
+            </a:ln>
+          </p:spPr>
+          <p:style>
+            <a:lnRef idx="1">
+              <a:schemeClr val="accent1"/>
+            </a:lnRef>
+            <a:fillRef idx="3">
+              <a:schemeClr val="accent1"/>
+            </a:fillRef>
+            <a:effectRef idx="2">
+              <a:schemeClr val="accent1"/>
+            </a:effectRef>
+            <a:fontRef idx="minor">
+              <a:schemeClr val="lt1"/>
+            </a:fontRef>
+          </p:style>
+          <p:txBody>
+            <a:bodyPr rtlCol="0" anchor="ctr"/>
+            <a:lstStyle/>
+            <a:p/>
+          </p:txBody>
+        </p:sp>
+        <p:sp>
+          <p:nvSpPr>
+            <p:cNvPr id="33" name="TextBox 32"/>
+            <p:cNvSpPr txBox="1"/>
+            <p:nvPr/>
+          </p:nvSpPr>
+          <p:spPr>
+            <a:xfrm>
+              <a:off x="8864600" y="2388195"/>
+              <a:ext cx="5562600" cy="355600"/>
+            </a:xfrm>
+            <a:prstGeom prst="rect">
+              <a:avLst/>
+            </a:prstGeom>
+            <a:noFill/>
+          </p:spPr>
+          <p:txBody>
+            <a:bodyPr wrap="none" lIns="0" rIns="0" tIns="0" bIns="0" anchor="t"/>
+            <a:lstStyle/>
+            <a:p>
+              <a:pPr algn="l">
+                <a:lnSpc>
+                  <a:spcPct val="120000"/>
+                </a:lnSpc>
+              </a:pPr>
+              <a:r>
+                <a:rPr sz="2400" b="1" i="0">
+                  <a:solidFill>
+                    <a:srgbClr val="003040"/>
+                  </a:solidFill>
+                  <a:latin typeface="Roboto"/>
+                </a:rPr>
+                <a:t>Gestiona integrat</a:t>
+              </a:r>
+            </a:p>
+          </p:txBody>
+        </p:sp>
+        <p:sp>
+          <p:nvSpPr>
+            <p:cNvPr id="34" name="TextBox 33"/>
+            <p:cNvSpPr txBox="1"/>
+            <p:nvPr/>
+          </p:nvSpPr>
+          <p:spPr>
+            <a:xfrm>
+              <a:off x="8864600" y="2870795"/>
+              <a:ext cx="5511800" cy="828675"/>
+            </a:xfrm>
+            <a:prstGeom prst="rect">
+              <a:avLst/>
+            </a:prstGeom>
+            <a:noFill/>
+          </p:spPr>
+          <p:txBody>
+            <a:bodyPr wrap="square" lIns="0" rIns="0" tIns="0" bIns="0" anchor="t"/>
+            <a:lstStyle/>
+            <a:p>
+              <a:pPr algn="l">
+                <a:lnSpc>
+                  <a:spcPct val="150000"/>
+                </a:lnSpc>
+              </a:pPr>
+              <a:r>
+                <a:rPr sz="1500" b="0" i="0">
+                  <a:solidFill>
+                    <a:srgbClr val="3D5C66"/>
+                  </a:solidFill>
+                  <a:latin typeface="Roboto"/>
+                </a:rPr>
+                <a:t>Condicionem la data d'arrencada al desenvolupament d'un projecte de Gestiona integrat.</a:t>
+              </a:r>
+            </a:p>
+          </p:txBody>
+        </p:sp>
+        <p:sp>
+          <p:nvSpPr>
+            <p:cNvPr id="35" name="TextBox 34"/>
+            <p:cNvSpPr txBox="1"/>
+            <p:nvPr/>
+          </p:nvSpPr>
+          <p:spPr>
+            <a:xfrm>
+              <a:off x="8864600" y="4004270"/>
+              <a:ext cx="5562600" cy="731441"/>
+            </a:xfrm>
+            <a:prstGeom prst="rect">
+              <a:avLst/>
+            </a:prstGeom>
+            <a:noFill/>
+          </p:spPr>
+          <p:txBody>
+            <a:bodyPr wrap="none" lIns="0" rIns="0" tIns="0" bIns="0" anchor="t"/>
+            <a:lstStyle/>
+            <a:p>
+              <a:pPr algn="l">
+                <a:lnSpc>
+                  <a:spcPct val="100000"/>
+                </a:lnSpc>
+              </a:pPr>
+              <a:r>
+                <a:rPr sz="5760" b="1" i="0">
+                  <a:solidFill>
+                    <a:srgbClr val="7FB927"/>
+                  </a:solidFill>
+                  <a:latin typeface="Roboto"/>
+                </a:rPr>
+                <a:t>3T 2027</a:t>
+              </a:r>
+            </a:p>
+          </p:txBody>
+        </p:sp>
+        <p:sp>
+          <p:nvSpPr>
+            <p:cNvPr id="36" name="TextBox 35"/>
+            <p:cNvSpPr txBox="1"/>
+            <p:nvPr/>
+          </p:nvSpPr>
+          <p:spPr>
+            <a:xfrm>
+              <a:off x="8864600" y="4811911"/>
+              <a:ext cx="5562600" cy="228600"/>
+            </a:xfrm>
+            <a:prstGeom prst="rect">
+              <a:avLst/>
+            </a:prstGeom>
+            <a:noFill/>
+          </p:spPr>
+          <p:txBody>
+            <a:bodyPr wrap="none" lIns="0" rIns="0" tIns="0" bIns="0" anchor="t"/>
+            <a:lstStyle/>
+            <a:p>
+              <a:pPr algn="l">
+                <a:lnSpc>
+                  <a:spcPct val="120000"/>
+                </a:lnSpc>
+              </a:pPr>
+              <a:r>
+                <a:rPr sz="1520" b="0" i="0">
+                  <a:solidFill>
+                    <a:srgbClr val="3D5C66"/>
+                  </a:solidFill>
+                  <a:latin typeface="Roboto"/>
+                </a:rPr>
+                <a:t>Arrencada · 17 de setembre de 2027</a:t>
+              </a:r>
+            </a:p>
+          </p:txBody>
+        </p:sp>
+        <p:sp>
+          <p:nvSpPr>
+            <p:cNvPr id="37" name="Rectangle 36"/>
+            <p:cNvSpPr/>
+            <p:nvPr/>
+          </p:nvSpPr>
+          <p:spPr>
+            <a:xfrm>
+              <a:off x="8864600" y="5396111"/>
+              <a:ext cx="5486400" cy="495300"/>
+            </a:xfrm>
+            <a:prstGeom prst="rect">
+              <a:avLst/>
+            </a:prstGeom>
+            <a:noFill/>
+            <a:effectLst/>
+            <a:ln>
+              <a:noFill/>
+            </a:ln>
+          </p:spPr>
+          <p:style>
+            <a:lnRef idx="1">
+              <a:schemeClr val="accent1"/>
+            </a:lnRef>
+            <a:fillRef idx="3">
+              <a:schemeClr val="accent1"/>
+            </a:fillRef>
+            <a:effectRef idx="2">
+              <a:schemeClr val="accent1"/>
+            </a:effectRef>
+            <a:fontRef idx="minor">
+              <a:schemeClr val="lt1"/>
+            </a:fontRef>
+          </p:style>
+          <p:txBody>
+            <a:bodyPr rtlCol="0" anchor="ctr"/>
+            <a:lstStyle/>
+            <a:p/>
+          </p:txBody>
+        </p:sp>
+        <p:sp>
+          <p:nvSpPr>
+            <p:cNvPr id="38" name="Rectangle 37"/>
+            <p:cNvSpPr/>
+            <p:nvPr/>
+          </p:nvSpPr>
+          <p:spPr>
+            <a:xfrm>
+              <a:off x="8864600" y="5396111"/>
+              <a:ext cx="5486400" cy="12700"/>
+            </a:xfrm>
+            <a:prstGeom prst="rect">
+              <a:avLst/>
+            </a:prstGeom>
+            <a:solidFill>
+              <a:srgbClr val="D4DEE3"/>
+            </a:solidFill>
+            <a:effectLst/>
+            <a:ln>
+              <a:noFill/>
+            </a:ln>
+          </p:spPr>
+          <p:style>
+            <a:lnRef idx="1">
+              <a:schemeClr val="accent1"/>
+            </a:lnRef>
+            <a:fillRef idx="3">
+              <a:schemeClr val="accent1"/>
+            </a:fillRef>
+            <a:effectRef idx="2">
+              <a:schemeClr val="accent1"/>
+            </a:effectRef>
+            <a:fontRef idx="minor">
+              <a:schemeClr val="lt1"/>
+            </a:fontRef>
+          </p:style>
+          <p:txBody>
+            <a:bodyPr rtlCol="0" anchor="ctr"/>
+            <a:lstStyle/>
+            <a:p/>
+          </p:txBody>
+        </p:sp>
+        <p:sp>
+          <p:nvSpPr>
+            <p:cNvPr id="39" name="TextBox 38"/>
+            <p:cNvSpPr txBox="1"/>
+            <p:nvPr/>
+          </p:nvSpPr>
+          <p:spPr>
+            <a:xfrm>
+              <a:off x="8864600" y="5535811"/>
+              <a:ext cx="1437084" cy="228600"/>
+            </a:xfrm>
+            <a:prstGeom prst="rect">
+              <a:avLst/>
+            </a:prstGeom>
+            <a:noFill/>
+          </p:spPr>
+          <p:txBody>
+            <a:bodyPr wrap="none" lIns="0" rIns="0" tIns="0" bIns="0" anchor="t"/>
+            <a:lstStyle/>
+            <a:p>
+              <a:pPr algn="l">
+                <a:lnSpc>
+                  <a:spcPct val="120000"/>
+                </a:lnSpc>
+              </a:pPr>
+              <a:r>
+                <a:rPr sz="1472" b="0" i="0">
+                  <a:solidFill>
+                    <a:srgbClr val="3D5C66"/>
+                  </a:solidFill>
+                  <a:latin typeface="Roboto"/>
+                </a:rPr>
+                <a:t>Inici del projecte</a:t>
+              </a:r>
+            </a:p>
+          </p:txBody>
+        </p:sp>
+        <p:sp>
+          <p:nvSpPr>
+            <p:cNvPr id="40" name="TextBox 39"/>
+            <p:cNvSpPr txBox="1"/>
+            <p:nvPr/>
+          </p:nvSpPr>
+          <p:spPr>
+            <a:xfrm>
+              <a:off x="13305433" y="5535811"/>
+              <a:ext cx="1045567" cy="228600"/>
+            </a:xfrm>
+            <a:prstGeom prst="rect">
+              <a:avLst/>
+            </a:prstGeom>
+            <a:noFill/>
+          </p:spPr>
+          <p:txBody>
+            <a:bodyPr wrap="none" lIns="0" rIns="0" tIns="0" bIns="0" anchor="t"/>
+            <a:lstStyle/>
+            <a:p>
+              <a:pPr algn="r">
+                <a:lnSpc>
+                  <a:spcPct val="120000"/>
+                </a:lnSpc>
+              </a:pPr>
+              <a:r>
+                <a:rPr sz="1472" b="0" i="0">
+                  <a:solidFill>
+                    <a:srgbClr val="003040"/>
+                  </a:solidFill>
+                  <a:latin typeface="Roboto"/>
+                </a:rPr>
+                <a:t>Gener 2027</a:t>
+              </a:r>
+            </a:p>
+          </p:txBody>
+        </p:sp>
+        <p:sp>
+          <p:nvSpPr>
+            <p:cNvPr id="41" name="Rectangle 40"/>
+            <p:cNvSpPr/>
+            <p:nvPr/>
+          </p:nvSpPr>
+          <p:spPr>
+            <a:xfrm>
+              <a:off x="8864600" y="5891411"/>
+              <a:ext cx="5486400" cy="495300"/>
+            </a:xfrm>
+            <a:prstGeom prst="rect">
+              <a:avLst/>
+            </a:prstGeom>
+            <a:noFill/>
+            <a:effectLst/>
+            <a:ln>
+              <a:noFill/>
+            </a:ln>
+          </p:spPr>
+          <p:style>
+            <a:lnRef idx="1">
+              <a:schemeClr val="accent1"/>
+            </a:lnRef>
+            <a:fillRef idx="3">
+              <a:schemeClr val="accent1"/>
+            </a:fillRef>
+            <a:effectRef idx="2">
+              <a:schemeClr val="accent1"/>
+            </a:effectRef>
+            <a:fontRef idx="minor">
+              <a:schemeClr val="lt1"/>
+            </a:fontRef>
+          </p:style>
+          <p:txBody>
+            <a:bodyPr rtlCol="0" anchor="ctr"/>
+            <a:lstStyle/>
+            <a:p/>
+          </p:txBody>
+        </p:sp>
+        <p:sp>
+          <p:nvSpPr>
+            <p:cNvPr id="42" name="Rectangle 41"/>
+            <p:cNvSpPr/>
+            <p:nvPr/>
+          </p:nvSpPr>
+          <p:spPr>
+            <a:xfrm>
+              <a:off x="8864600" y="5891411"/>
+              <a:ext cx="5486400" cy="12700"/>
+            </a:xfrm>
+            <a:prstGeom prst="rect">
+              <a:avLst/>
+            </a:prstGeom>
+            <a:solidFill>
+              <a:srgbClr val="D4DEE3"/>
+            </a:solidFill>
+            <a:effectLst/>
+            <a:ln>
+              <a:noFill/>
+            </a:ln>
+          </p:spPr>
+          <p:style>
+            <a:lnRef idx="1">
+              <a:schemeClr val="accent1"/>
+            </a:lnRef>
+            <a:fillRef idx="3">
+              <a:schemeClr val="accent1"/>
+            </a:fillRef>
+            <a:effectRef idx="2">
+              <a:schemeClr val="accent1"/>
+            </a:effectRef>
+            <a:fontRef idx="minor">
+              <a:schemeClr val="lt1"/>
+            </a:fontRef>
+          </p:style>
+          <p:txBody>
+            <a:bodyPr rtlCol="0" anchor="ctr"/>
+            <a:lstStyle/>
+            <a:p/>
+          </p:txBody>
+        </p:sp>
+        <p:sp>
+          <p:nvSpPr>
+            <p:cNvPr id="43" name="TextBox 42"/>
+            <p:cNvSpPr txBox="1"/>
+            <p:nvPr/>
+          </p:nvSpPr>
+          <p:spPr>
+            <a:xfrm>
+              <a:off x="8864600" y="6031111"/>
+              <a:ext cx="1887141" cy="228600"/>
+            </a:xfrm>
+            <a:prstGeom prst="rect">
+              <a:avLst/>
+            </a:prstGeom>
+            <a:noFill/>
+          </p:spPr>
+          <p:txBody>
+            <a:bodyPr wrap="none" lIns="0" rIns="0" tIns="0" bIns="0" anchor="t"/>
+            <a:lstStyle/>
+            <a:p>
+              <a:pPr algn="l">
+                <a:lnSpc>
+                  <a:spcPct val="120000"/>
+                </a:lnSpc>
+              </a:pPr>
+              <a:r>
+                <a:rPr sz="1472" b="0" i="0">
+                  <a:solidFill>
+                    <a:srgbClr val="3D5C66"/>
+                  </a:solidFill>
+                  <a:latin typeface="Roboto"/>
+                </a:rPr>
+                <a:t>Migració d'expedients</a:t>
+              </a:r>
+            </a:p>
+          </p:txBody>
+        </p:sp>
+        <p:sp>
+          <p:nvSpPr>
+            <p:cNvPr id="44" name="TextBox 43"/>
+            <p:cNvSpPr txBox="1"/>
+            <p:nvPr/>
+          </p:nvSpPr>
+          <p:spPr>
+            <a:xfrm>
+              <a:off x="12249150" y="6031111"/>
+              <a:ext cx="2101850" cy="228600"/>
+            </a:xfrm>
+            <a:prstGeom prst="rect">
+              <a:avLst/>
+            </a:prstGeom>
+            <a:noFill/>
+          </p:spPr>
+          <p:txBody>
+            <a:bodyPr wrap="none" lIns="0" rIns="0" tIns="0" bIns="0" anchor="t"/>
+            <a:lstStyle/>
+            <a:p>
+              <a:pPr algn="r">
+                <a:lnSpc>
+                  <a:spcPct val="120000"/>
+                </a:lnSpc>
+              </a:pPr>
+              <a:r>
+                <a:rPr sz="1472" b="0" i="0">
+                  <a:solidFill>
+                    <a:srgbClr val="003040"/>
+                  </a:solidFill>
+                  <a:latin typeface="Roboto"/>
+                </a:rPr>
+                <a:t>17 de setembre de 2027</a:t>
+              </a:r>
+            </a:p>
+          </p:txBody>
+        </p:sp>
+        <p:sp>
+          <p:nvSpPr>
+            <p:cNvPr id="45" name="Rectangle 44"/>
+            <p:cNvSpPr/>
+            <p:nvPr/>
+          </p:nvSpPr>
+          <p:spPr>
+            <a:xfrm>
+              <a:off x="8864600" y="6386711"/>
+              <a:ext cx="5486400" cy="495300"/>
+            </a:xfrm>
+            <a:prstGeom prst="rect">
+              <a:avLst/>
+            </a:prstGeom>
+            <a:noFill/>
+            <a:effectLst/>
+            <a:ln>
+              <a:noFill/>
+            </a:ln>
+          </p:spPr>
+          <p:style>
+            <a:lnRef idx="1">
+              <a:schemeClr val="accent1"/>
+            </a:lnRef>
+            <a:fillRef idx="3">
+              <a:schemeClr val="accent1"/>
+            </a:fillRef>
+            <a:effectRef idx="2">
+              <a:schemeClr val="accent1"/>
+            </a:effectRef>
+            <a:fontRef idx="minor">
+              <a:schemeClr val="lt1"/>
+            </a:fontRef>
+          </p:style>
+          <p:txBody>
+            <a:bodyPr rtlCol="0" anchor="ctr"/>
+            <a:lstStyle/>
+            <a:p/>
+          </p:txBody>
+        </p:sp>
+        <p:sp>
+          <p:nvSpPr>
+            <p:cNvPr id="46" name="Rectangle 45"/>
+            <p:cNvSpPr/>
+            <p:nvPr/>
+          </p:nvSpPr>
+          <p:spPr>
+            <a:xfrm>
+              <a:off x="8864600" y="6386711"/>
+              <a:ext cx="5486400" cy="12700"/>
+            </a:xfrm>
+            <a:prstGeom prst="rect">
+              <a:avLst/>
+            </a:prstGeom>
+            <a:solidFill>
+              <a:srgbClr val="D4DEE3"/>
+            </a:solidFill>
+            <a:effectLst/>
+            <a:ln>
+              <a:noFill/>
+            </a:ln>
+          </p:spPr>
+          <p:style>
+            <a:lnRef idx="1">
+              <a:schemeClr val="accent1"/>
+            </a:lnRef>
+            <a:fillRef idx="3">
+              <a:schemeClr val="accent1"/>
+            </a:fillRef>
+            <a:effectRef idx="2">
+              <a:schemeClr val="accent1"/>
+            </a:effectRef>
+            <a:fontRef idx="minor">
+              <a:schemeClr val="lt1"/>
+            </a:fontRef>
+          </p:style>
+          <p:txBody>
+            <a:bodyPr rtlCol="0" anchor="ctr"/>
+            <a:lstStyle/>
+            <a:p/>
+          </p:txBody>
+        </p:sp>
+        <p:sp>
+          <p:nvSpPr>
+            <p:cNvPr id="47" name="TextBox 46"/>
+            <p:cNvSpPr txBox="1"/>
+            <p:nvPr/>
+          </p:nvSpPr>
+          <p:spPr>
+            <a:xfrm>
+              <a:off x="8864600" y="6526411"/>
+              <a:ext cx="1867694" cy="228600"/>
+            </a:xfrm>
+            <a:prstGeom prst="rect">
+              <a:avLst/>
+            </a:prstGeom>
+            <a:noFill/>
+          </p:spPr>
+          <p:txBody>
+            <a:bodyPr wrap="none" lIns="0" rIns="0" tIns="0" bIns="0" anchor="t"/>
+            <a:lstStyle/>
+            <a:p>
+              <a:pPr algn="l">
+                <a:lnSpc>
+                  <a:spcPct val="120000"/>
+                </a:lnSpc>
+              </a:pPr>
+              <a:r>
+                <a:rPr sz="1472" b="0" i="0">
+                  <a:solidFill>
+                    <a:srgbClr val="3D5C66"/>
+                  </a:solidFill>
+                  <a:latin typeface="Roboto"/>
+                </a:rPr>
+                <a:t>Evolutius de producte</a:t>
+              </a:r>
+            </a:p>
+          </p:txBody>
+        </p:sp>
+        <p:sp>
+          <p:nvSpPr>
+            <p:cNvPr id="48" name="TextBox 47"/>
+            <p:cNvSpPr txBox="1"/>
+            <p:nvPr/>
+          </p:nvSpPr>
+          <p:spPr>
+            <a:xfrm>
+              <a:off x="12249150" y="6526411"/>
+              <a:ext cx="2101850" cy="228600"/>
+            </a:xfrm>
+            <a:prstGeom prst="rect">
+              <a:avLst/>
+            </a:prstGeom>
+            <a:noFill/>
+          </p:spPr>
+          <p:txBody>
+            <a:bodyPr wrap="none" lIns="0" rIns="0" tIns="0" bIns="0" anchor="t"/>
+            <a:lstStyle/>
+            <a:p>
+              <a:pPr algn="r">
+                <a:lnSpc>
+                  <a:spcPct val="120000"/>
+                </a:lnSpc>
+              </a:pPr>
+              <a:r>
+                <a:rPr sz="1472" b="0" i="0">
+                  <a:solidFill>
+                    <a:srgbClr val="003040"/>
+                  </a:solidFill>
+                  <a:latin typeface="Roboto"/>
+                </a:rPr>
+                <a:t>17 de setembre de 2027</a:t>
+              </a:r>
+            </a:p>
+          </p:txBody>
+        </p:sp>
+        <p:sp>
+          <p:nvSpPr>
+            <p:cNvPr id="49" name="Rectangle 48"/>
+            <p:cNvSpPr/>
+            <p:nvPr/>
+          </p:nvSpPr>
+          <p:spPr>
+            <a:xfrm>
+              <a:off x="8864600" y="6882011"/>
+              <a:ext cx="5486400" cy="495300"/>
+            </a:xfrm>
+            <a:prstGeom prst="rect">
+              <a:avLst/>
+            </a:prstGeom>
+            <a:noFill/>
+            <a:effectLst/>
+            <a:ln>
+              <a:noFill/>
+            </a:ln>
+          </p:spPr>
+          <p:style>
+            <a:lnRef idx="1">
+              <a:schemeClr val="accent1"/>
+            </a:lnRef>
+            <a:fillRef idx="3">
+              <a:schemeClr val="accent1"/>
+            </a:fillRef>
+            <a:effectRef idx="2">
+              <a:schemeClr val="accent1"/>
+            </a:effectRef>
+            <a:fontRef idx="minor">
+              <a:schemeClr val="lt1"/>
+            </a:fontRef>
+          </p:style>
+          <p:txBody>
+            <a:bodyPr rtlCol="0" anchor="ctr"/>
+            <a:lstStyle/>
+            <a:p/>
+          </p:txBody>
+        </p:sp>
+        <p:sp>
+          <p:nvSpPr>
+            <p:cNvPr id="50" name="Rectangle 49"/>
+            <p:cNvSpPr/>
+            <p:nvPr/>
+          </p:nvSpPr>
+          <p:spPr>
+            <a:xfrm>
+              <a:off x="8864600" y="6882011"/>
+              <a:ext cx="5486400" cy="12700"/>
+            </a:xfrm>
+            <a:prstGeom prst="rect">
+              <a:avLst/>
+            </a:prstGeom>
+            <a:solidFill>
+              <a:srgbClr val="D4DEE3"/>
+            </a:solidFill>
+            <a:effectLst/>
+            <a:ln>
+              <a:noFill/>
+            </a:ln>
+          </p:spPr>
+          <p:style>
+            <a:lnRef idx="1">
+              <a:schemeClr val="accent1"/>
+            </a:lnRef>
+            <a:fillRef idx="3">
+              <a:schemeClr val="accent1"/>
+            </a:fillRef>
+            <a:effectRef idx="2">
+              <a:schemeClr val="accent1"/>
+            </a:effectRef>
+            <a:fontRef idx="minor">
+              <a:schemeClr val="lt1"/>
+            </a:fontRef>
+          </p:style>
+          <p:txBody>
+            <a:bodyPr rtlCol="0" anchor="ctr"/>
+            <a:lstStyle/>
+            <a:p/>
+          </p:txBody>
+        </p:sp>
+        <p:sp>
+          <p:nvSpPr>
+            <p:cNvPr id="51" name="TextBox 50"/>
+            <p:cNvSpPr txBox="1"/>
+            <p:nvPr/>
+          </p:nvSpPr>
+          <p:spPr>
+            <a:xfrm>
+              <a:off x="8864600" y="7021711"/>
+              <a:ext cx="2217341" cy="228600"/>
+            </a:xfrm>
+            <a:prstGeom prst="rect">
+              <a:avLst/>
+            </a:prstGeom>
+            <a:noFill/>
+          </p:spPr>
+          <p:txBody>
+            <a:bodyPr wrap="none" lIns="0" rIns="0" tIns="0" bIns="0" anchor="t"/>
+            <a:lstStyle/>
+            <a:p>
+              <a:pPr algn="l">
+                <a:lnSpc>
+                  <a:spcPct val="120000"/>
+                </a:lnSpc>
+              </a:pPr>
+              <a:r>
+                <a:rPr sz="1472" b="0" i="0">
+                  <a:solidFill>
+                    <a:srgbClr val="3D5C66"/>
+                  </a:solidFill>
+                  <a:latin typeface="Roboto"/>
+                </a:rPr>
+                <a:t>Projecte Gestiona Factory</a:t>
+              </a:r>
+            </a:p>
+          </p:txBody>
+        </p:sp>
+        <p:sp>
+          <p:nvSpPr>
+            <p:cNvPr id="52" name="TextBox 51"/>
+            <p:cNvSpPr txBox="1"/>
+            <p:nvPr/>
+          </p:nvSpPr>
+          <p:spPr>
+            <a:xfrm>
+              <a:off x="12301141" y="7021711"/>
+              <a:ext cx="2049859" cy="228600"/>
+            </a:xfrm>
+            <a:prstGeom prst="rect">
+              <a:avLst/>
+            </a:prstGeom>
+            <a:noFill/>
+          </p:spPr>
+          <p:txBody>
+            <a:bodyPr wrap="none" lIns="0" rIns="0" tIns="0" bIns="0" anchor="t"/>
+            <a:lstStyle/>
+            <a:p>
+              <a:pPr algn="r">
+                <a:lnSpc>
+                  <a:spcPct val="120000"/>
+                </a:lnSpc>
+              </a:pPr>
+              <a:r>
+                <a:rPr sz="1472" b="0" i="0">
+                  <a:solidFill>
+                    <a:srgbClr val="003040"/>
+                  </a:solidFill>
+                  <a:latin typeface="Roboto"/>
+                </a:rPr>
+                <a:t>Gener – setembre 2027</a:t>
+              </a:r>
+            </a:p>
+          </p:txBody>
+        </p:sp>
+      </p:grpSp>
+      <p:grpSp>
+        <p:nvGrpSpPr>
+          <p:cNvPr id="53" name="Fase 1"/>
+          <p:cNvGrpSpPr/>
+          <p:nvPr/>
+        </p:nvGrpSpPr>
+        <p:grpSpPr>
+          <a:xfrm>
+            <a:off x="1397000" y="8037711"/>
             <a:ext cx="13538200" cy="267494"/>
-          </a:xfrm>
-          <a:prstGeom prst="rect">
-            <a:avLst/>
-          </a:prstGeom>
-          <a:noFill/>
-        </p:spPr>
-        <p:txBody>
-          <a:bodyPr wrap="none" lIns="0" rIns="0" tIns="0" bIns="0" anchor="t"/>
-          <a:lstStyle/>
-          <a:p>
-            <a:pPr algn="l">
-              <a:lnSpc>
-                <a:spcPct val="154999"/>
-              </a:lnSpc>
-            </a:pPr>
-            <a:r>
-              <a:rPr sz="1360" b="0" i="0">
-                <a:solidFill>
-                  <a:srgbClr val="3D5C66"/>
-                </a:solidFill>
-                <a:latin typeface="Roboto"/>
-              </a:rPr>
-              <a:t>* Data condicionada al desplegament dels evolutius de producte.</a:t>
-            </a:r>
-          </a:p>
-        </p:txBody>
-      </p:sp>
-      <p:sp>
-        <p:nvSpPr>
-          <p:cNvPr id="48" name="TextBox 47"/>
+            <a:chOff x="1397000" y="8037711"/>
+            <a:chExt cx="13538200" cy="267494"/>
+          </a:xfrm>
+        </p:grpSpPr>
+        <p:sp>
+          <p:nvSpPr>
+            <p:cNvPr id="54" name="TextBox 53"/>
+            <p:cNvSpPr txBox="1"/>
+            <p:nvPr/>
+          </p:nvSpPr>
+          <p:spPr>
+            <a:xfrm>
+              <a:off x="1397000" y="8037711"/>
+              <a:ext cx="13538200" cy="267494"/>
+            </a:xfrm>
+            <a:prstGeom prst="rect">
+              <a:avLst/>
+            </a:prstGeom>
+            <a:noFill/>
+          </p:spPr>
+          <p:txBody>
+            <a:bodyPr wrap="none" lIns="0" rIns="0" tIns="0" bIns="0" anchor="t"/>
+            <a:lstStyle/>
+            <a:p>
+              <a:pPr algn="l">
+                <a:lnSpc>
+                  <a:spcPct val="154999"/>
+                </a:lnSpc>
+              </a:pPr>
+              <a:r>
+                <a:rPr sz="1360" b="0" i="0">
+                  <a:solidFill>
+                    <a:srgbClr val="3D5C66"/>
+                  </a:solidFill>
+                  <a:latin typeface="Roboto"/>
+                </a:rPr>
+                <a:t>* Data condicionada al desplegament dels evolutius de producte.</a:t>
+              </a:r>
+            </a:p>
+          </p:txBody>
+        </p:sp>
+      </p:grpSp>
+      <p:sp>
+        <p:nvSpPr>
+          <p:cNvPr id="55" name="TextBox 54"/>
           <p:cNvSpPr txBox="1"/>
           <p:nvPr/>
         </p:nvSpPr>
@@ -9098,6 +9307,320 @@
       </p:transition>
     </mc:Fallback>
   </mc:AlternateContent>
+  <p:timing>
+    <p:tnLst>
+      <p:par>
+        <p:cTn id="1" dur="indefinite" restart="never" nodeType="tmRoot">
+          <p:childTnLst>
+            <p:seq concurrent="1" nextAc="seek">
+              <p:cTn id="2" dur="indefinite" nodeType="mainSeq">
+                <p:childTnLst>
+                  <p:par>
+                    <p:cTn id="3" fill="hold">
+                      <p:stCondLst>
+                        <p:cond delay="indefinite"/>
+                      </p:stCondLst>
+                      <p:childTnLst>
+                        <p:par>
+                          <p:cTn id="4" fill="hold">
+                            <p:stCondLst>
+                              <p:cond delay="0"/>
+                            </p:stCondLst>
+                            <p:childTnLst>
+                              <p:par>
+                                <p:cTn id="5" presetID="42" presetClass="entr" presetSubtype="0" fill="hold" grpId="0" nodeType="clickEffect">
+                                  <p:stCondLst>
+                                    <p:cond delay="0"/>
+                                  </p:stCondLst>
+                                  <p:childTnLst>
+                                    <p:set>
+                                      <p:cBhvr>
+                                        <p:cTn id="6" dur="1" fill="hold">
+                                          <p:stCondLst>
+                                            <p:cond delay="0"/>
+                                          </p:stCondLst>
+                                        </p:cTn>
+                                        <p:tgtEl>
+                                          <p:spTgt spid="7"/>
+                                        </p:tgtEl>
+                                        <p:attrNameLst>
+                                          <p:attrName>style.visibility</p:attrName>
+                                        </p:attrNameLst>
+                                      </p:cBhvr>
+                                      <p:to>
+                                        <p:strVal val="visible"/>
+                                      </p:to>
+                                    </p:set>
+                                    <p:animEffect transition="in" filter="fade">
+                                      <p:cBhvr>
+                                        <p:cTn id="7" dur="500"/>
+                                        <p:tgtEl>
+                                          <p:spTgt spid="7"/>
+                                        </p:tgtEl>
+                                      </p:cBhvr>
+                                    </p:animEffect>
+                                    <p:anim calcmode="lin" valueType="num">
+                                      <p:cBhvr>
+                                        <p:cTn id="8" dur="500" decel="100000" fill="hold"/>
+                                        <p:tgtEl>
+                                          <p:spTgt spid="7"/>
+                                        </p:tgtEl>
+                                        <p:attrNameLst>
+                                          <p:attrName>ppt_x</p:attrName>
+                                        </p:attrNameLst>
+                                      </p:cBhvr>
+                                      <p:tavLst>
+                                        <p:tav tm="0">
+                                          <p:val>
+                                            <p:strVal val="#ppt_x"/>
+                                          </p:val>
+                                        </p:tav>
+                                        <p:tav tm="100000">
+                                          <p:val>
+                                            <p:strVal val="#ppt_x"/>
+                                          </p:val>
+                                        </p:tav>
+                                      </p:tavLst>
+                                    </p:anim>
+                                    <p:anim calcmode="lin" valueType="num">
+                                      <p:cBhvr>
+                                        <p:cTn id="9" dur="500" decel="100000" fill="hold"/>
+                                        <p:tgtEl>
+                                          <p:spTgt spid="7"/>
+                                        </p:tgtEl>
+                                        <p:attrNameLst>
+                                          <p:attrName>ppt_y</p:attrName>
+                                        </p:attrNameLst>
+                                      </p:cBhvr>
+                                      <p:tavLst>
+                                        <p:tav tm="0">
+                                          <p:val>
+                                            <p:strVal val="#ppt_y+0.0167"/>
+                                          </p:val>
+                                        </p:tav>
+                                        <p:tav tm="100000">
+                                          <p:val>
+                                            <p:strVal val="#ppt_y"/>
+                                          </p:val>
+                                        </p:tav>
+                                      </p:tavLst>
+                                    </p:anim>
+                                  </p:childTnLst>
+                                </p:cTn>
+                              </p:par>
+                              <p:par>
+                                <p:cTn id="10" presetID="42" presetClass="entr" presetSubtype="0" fill="hold" grpId="0" nodeType="withEffect">
+                                  <p:stCondLst>
+                                    <p:cond delay="0"/>
+                                  </p:stCondLst>
+                                  <p:childTnLst>
+                                    <p:set>
+                                      <p:cBhvr>
+                                        <p:cTn id="11" dur="1" fill="hold">
+                                          <p:stCondLst>
+                                            <p:cond delay="0"/>
+                                          </p:stCondLst>
+                                        </p:cTn>
+                                        <p:tgtEl>
+                                          <p:spTgt spid="53"/>
+                                        </p:tgtEl>
+                                        <p:attrNameLst>
+                                          <p:attrName>style.visibility</p:attrName>
+                                        </p:attrNameLst>
+                                      </p:cBhvr>
+                                      <p:to>
+                                        <p:strVal val="visible"/>
+                                      </p:to>
+                                    </p:set>
+                                    <p:animEffect transition="in" filter="fade">
+                                      <p:cBhvr>
+                                        <p:cTn id="12" dur="500"/>
+                                        <p:tgtEl>
+                                          <p:spTgt spid="53"/>
+                                        </p:tgtEl>
+                                      </p:cBhvr>
+                                    </p:animEffect>
+                                    <p:anim calcmode="lin" valueType="num">
+                                      <p:cBhvr>
+                                        <p:cTn id="13" dur="500" decel="100000" fill="hold"/>
+                                        <p:tgtEl>
+                                          <p:spTgt spid="53"/>
+                                        </p:tgtEl>
+                                        <p:attrNameLst>
+                                          <p:attrName>ppt_x</p:attrName>
+                                        </p:attrNameLst>
+                                      </p:cBhvr>
+                                      <p:tavLst>
+                                        <p:tav tm="0">
+                                          <p:val>
+                                            <p:strVal val="#ppt_x"/>
+                                          </p:val>
+                                        </p:tav>
+                                        <p:tav tm="100000">
+                                          <p:val>
+                                            <p:strVal val="#ppt_x"/>
+                                          </p:val>
+                                        </p:tav>
+                                      </p:tavLst>
+                                    </p:anim>
+                                    <p:anim calcmode="lin" valueType="num">
+                                      <p:cBhvr>
+                                        <p:cTn id="14" dur="500" decel="100000" fill="hold"/>
+                                        <p:tgtEl>
+                                          <p:spTgt spid="53"/>
+                                        </p:tgtEl>
+                                        <p:attrNameLst>
+                                          <p:attrName>ppt_y</p:attrName>
+                                        </p:attrNameLst>
+                                      </p:cBhvr>
+                                      <p:tavLst>
+                                        <p:tav tm="0">
+                                          <p:val>
+                                            <p:strVal val="#ppt_y+0.0167"/>
+                                          </p:val>
+                                        </p:tav>
+                                        <p:tav tm="100000">
+                                          <p:val>
+                                            <p:strVal val="#ppt_y"/>
+                                          </p:val>
+                                        </p:tav>
+                                      </p:tavLst>
+                                    </p:anim>
+                                  </p:childTnLst>
+                                </p:cTn>
+                              </p:par>
+                            </p:childTnLst>
+                          </p:cTn>
+                        </p:par>
+                      </p:childTnLst>
+                    </p:cTn>
+                  </p:par>
+                  <p:par>
+                    <p:cTn id="15" fill="hold">
+                      <p:stCondLst>
+                        <p:cond delay="indefinite"/>
+                      </p:stCondLst>
+                      <p:childTnLst>
+                        <p:par>
+                          <p:cTn id="16" fill="hold">
+                            <p:stCondLst>
+                              <p:cond delay="0"/>
+                            </p:stCondLst>
+                            <p:childTnLst>
+                              <p:par>
+                                <p:cTn id="17" presetID="42" presetClass="entr" presetSubtype="0" fill="hold" grpId="0" nodeType="clickEffect">
+                                  <p:stCondLst>
+                                    <p:cond delay="0"/>
+                                  </p:stCondLst>
+                                  <p:childTnLst>
+                                    <p:set>
+                                      <p:cBhvr>
+                                        <p:cTn id="18" dur="1" fill="hold">
+                                          <p:stCondLst>
+                                            <p:cond delay="0"/>
+                                          </p:stCondLst>
+                                        </p:cTn>
+                                        <p:tgtEl>
+                                          <p:spTgt spid="30"/>
+                                        </p:tgtEl>
+                                        <p:attrNameLst>
+                                          <p:attrName>style.visibility</p:attrName>
+                                        </p:attrNameLst>
+                                      </p:cBhvr>
+                                      <p:to>
+                                        <p:strVal val="visible"/>
+                                      </p:to>
+                                    </p:set>
+                                    <p:animEffect transition="in" filter="fade">
+                                      <p:cBhvr>
+                                        <p:cTn id="19" dur="500"/>
+                                        <p:tgtEl>
+                                          <p:spTgt spid="30"/>
+                                        </p:tgtEl>
+                                      </p:cBhvr>
+                                    </p:animEffect>
+                                    <p:anim calcmode="lin" valueType="num">
+                                      <p:cBhvr>
+                                        <p:cTn id="20" dur="500" decel="100000" fill="hold"/>
+                                        <p:tgtEl>
+                                          <p:spTgt spid="30"/>
+                                        </p:tgtEl>
+                                        <p:attrNameLst>
+                                          <p:attrName>ppt_x</p:attrName>
+                                        </p:attrNameLst>
+                                      </p:cBhvr>
+                                      <p:tavLst>
+                                        <p:tav tm="0">
+                                          <p:val>
+                                            <p:strVal val="#ppt_x"/>
+                                          </p:val>
+                                        </p:tav>
+                                        <p:tav tm="100000">
+                                          <p:val>
+                                            <p:strVal val="#ppt_x"/>
+                                          </p:val>
+                                        </p:tav>
+                                      </p:tavLst>
+                                    </p:anim>
+                                    <p:anim calcmode="lin" valueType="num">
+                                      <p:cBhvr>
+                                        <p:cTn id="21" dur="500" decel="100000" fill="hold"/>
+                                        <p:tgtEl>
+                                          <p:spTgt spid="30"/>
+                                        </p:tgtEl>
+                                        <p:attrNameLst>
+                                          <p:attrName>ppt_y</p:attrName>
+                                        </p:attrNameLst>
+                                      </p:cBhvr>
+                                      <p:tavLst>
+                                        <p:tav tm="0">
+                                          <p:val>
+                                            <p:strVal val="#ppt_y+0.0167"/>
+                                          </p:val>
+                                        </p:tav>
+                                        <p:tav tm="100000">
+                                          <p:val>
+                                            <p:strVal val="#ppt_y"/>
+                                          </p:val>
+                                        </p:tav>
+                                      </p:tavLst>
+                                    </p:anim>
+                                  </p:childTnLst>
+                                </p:cTn>
+                              </p:par>
+                            </p:childTnLst>
+                          </p:cTn>
+                        </p:par>
+                      </p:childTnLst>
+                    </p:cTn>
+                  </p:par>
+                </p:childTnLst>
+              </p:cTn>
+              <p:prevCondLst>
+                <p:cond evt="onPrev" delay="0">
+                  <p:tgtEl>
+                    <p:sldTgt/>
+                  </p:tgtEl>
+                </p:cond>
+              </p:prevCondLst>
+              <p:nextCondLst>
+                <p:cond evt="onNext" delay="0">
+                  <p:tgtEl>
+                    <p:sldTgt/>
+                  </p:tgtEl>
+                </p:cond>
+              </p:nextCondLst>
+            </p:seq>
+          </p:childTnLst>
+        </p:cTn>
+      </p:par>
+    </p:tnLst>
+    <p:bldLst>
+      <p:bldP spid="7" grpId="0"/>
+      <p:bldP spid="53" grpId="0"/>
+      <p:bldP spid="30" grpId="0"/>
+    </p:bldLst>
+  </p:timing>
 </p:sld>
 </file>
 

</xml_diff>

<commit_message>
feat(apdcat-migracio): rename legal milestone and shorten options footnote
Co-Authored-By: Claude Opus 5.5 <noreply@anthropic.com>
</commit_message>
<xml_diff>
--- a/apdcat-migracio/apdcat-migracio.pptx
+++ b/apdcat-migracio/apdcat-migracio.pptx
@@ -6018,7 +6018,7 @@
                   </a:solidFill>
                   <a:latin typeface="Roboto"/>
                 </a:rPr>
-                <a:t>Operació ordinària</a:t>
+                <a:t>Activació mòdul Direcció</a:t>
               </a:r>
             </a:p>
           </p:txBody>
@@ -9247,7 +9247,7 @@
                   </a:solidFill>
                   <a:latin typeface="Roboto"/>
                 </a:rPr>
-                <a:t>* Data condicionada al desplegament dels evolutius de producte.</a:t>
+                <a:t>* Data condicionada al desplegament.</a:t>
               </a:r>
             </a:p>
           </p:txBody>

</xml_diff>